<commit_message>
Review 2 slides: state the blind topic check result
</commit_message>
<xml_diff>
--- a/slides/review2.pptx
+++ b/slides/review2.pptx
@@ -1447,7 +1447,7 @@
           </a:p>
           <a:p>
             <a:r>
-              <a:t>Pipeline left to right. Be upfront that LDA scores better on UMass; the choice of NMF is about interpretability. Say that the manual 200-review check is being redone with blind labels.</a:t>
+              <a:t>Pipeline left to right. Be upfront that LDA scores better on UMass; the choice of NMF is about interpretability. The blind 200-review check was labelled by an AI assistant with the model topic hidden: 35.5% agreement, kappa 0.30, 73 reviews with no clear theme; well recovered are Early Access (88%), repetition (64%) and multiplayer and crashes (60%). An earlier 96% figure was withdrawn because those labels were not independent.</a:t>
             </a:r>
           </a:p>
         </p:txBody>
@@ -6507,7 +6507,7 @@
                 </a:solidFill>
                 <a:latin typeface="Bitstream Charter"/>
               </a:rPr>
-              <a:t>A blind manual check of 200 labelled reviews is being redone, so we do not quote an agreement figure.</a:t>
+              <a:t>Blind check of 200 reviews (labelled by an AI assistant): 35.5% agreement, kappa 0.30. Early Access, repetition and crash topics hold up; boss and balance topics do not.</a:t>
             </a:r>
           </a:p>
         </p:txBody>
@@ -6894,6 +6894,38 @@
                 <a:latin typeface="Bitstream Charter"/>
               </a:rPr>
               <a:t>“boring” is in 9.1% of negative reviews against 0.8% of positive ones, “waste” 2.9% against 0.3%.</a:t>
+            </a:r>
+          </a:p>
+          <a:p>
+            <a:pPr>
+              <a:spcAft>
+                <a:spcPts val="600"/>
+              </a:spcAft>
+            </a:pPr>
+            <a:r>
+              <a:rPr sz="1150" b="1" i="0">
+                <a:solidFill>
+                  <a:srgbClr val="132C43"/>
+                </a:solidFill>
+                <a:latin typeface="Bitstream Charter"/>
+              </a:rPr>
+              <a:t>Caution</a:t>
+            </a:r>
+          </a:p>
+          <a:p>
+            <a:pPr>
+              <a:spcAft>
+                <a:spcPts val="600"/>
+              </a:spcAft>
+            </a:pPr>
+            <a:r>
+              <a:rPr sz="1150" b="0" i="0">
+                <a:solidFill>
+                  <a:srgbClr val="263C50"/>
+                </a:solidFill>
+                <a:latin typeface="Bitstream Charter"/>
+              </a:rPr>
+              <a:t>In the blind check the boss and balance topics agree only 8% to 16%, so read them as exploratory.</a:t>
             </a:r>
           </a:p>
         </p:txBody>
@@ -12659,7 +12691,7 @@
                 </a:solidFill>
                 <a:latin typeface="Bitstream Charter"/>
               </a:rPr>
-              <a:t>Tuning gave small gains; the blind manual topic check is being redone; discount impact was not analysed.</a:t>
+              <a:t>Tuning gave small gains; the blind topic check agrees on only 35.5% of reviews (one AI annotator); discount impact was not analysed.</a:t>
             </a:r>
           </a:p>
         </p:txBody>
@@ -13398,7 +13430,7 @@
                 </a:solidFill>
                 <a:latin typeface="Bitstream Charter"/>
               </a:rPr>
-              <a:t>Redo the blind manual topic check.</a:t>
+              <a:t>Re-label a subset by hand to confirm the topic check.</a:t>
             </a:r>
           </a:p>
           <a:p>

</xml_diff>

<commit_message>
Game-level and review Logistic Regression grid searches, tuning integration
Adds the game-level grid searches (Logistic Regression, Random Forest, LightGBM,
XGBoost) and the review-level Logistic Regression search to grid_search.py,
reruns the comparison with a default-against-tuned table, and updates the
notes, protocol, report, slides, notebook addendum and README.

Co-authored-by: srihithathotakura <srihithathotakura@gmail.com>
</commit_message>
<xml_diff>
--- a/slides/review2.pptx
+++ b/slides/review2.pptx
@@ -1962,7 +1962,7 @@
           </a:p>
           <a:p xmlns:a="http://schemas.openxmlformats.org/drawingml/2006/main">
             <a:r>
-              <a:t>Same test records for every model. Guessing baselines: PR-AUC 0.106, macro-F1 0.22. Tuning by grid search changed cross-validation scores by 0.002 to 0.02 and did not change which models tie.</a:t>
+              <a:t>Same test records for every model. Guessing baselines: PR-AUC 0.106, macro-F1 0.22. Every model was tuned by grid search on the shared folds. Review-level gains were within one standard deviation; at game level the cross-validation gains for Random Forest and LightGBM did not carry to test, so quote the test intervals.</a:t>
             </a:r>
           </a:p>
         </p:txBody>
@@ -10254,7 +10254,7 @@
                           <a:ea typeface="Arial"/>
                           <a:cs typeface="Arial"/>
                         </a:rPr>
-                        <a:t>Exploratory analysis: 29 figures, association tests, tag combinations; dashboard pages</a:t>
+                        <a:t>Exploratory analysis: 29 figures, association tests, tag combinations; dashboard wireframe and CSV downloads</a:t>
                       </a:r>
                     </a:p>
                   </a:txBody>
@@ -10290,7 +10290,7 @@
                           <a:ea typeface="Arial"/>
                           <a:cs typeface="Arial"/>
                         </a:rPr>
-                        <a:t>PR #1, notebooks/02_EDA_Visualizations.ipynb; cards #20, #21</a:t>
+                        <a:t>PRs #1, #101, notebooks/02_EDA_Visualizations.ipynb; cards #20, #21, #37, #40, #41</a:t>
                       </a:r>
                     </a:p>
                   </a:txBody>
@@ -10522,7 +10522,7 @@
                           <a:ea typeface="Arial"/>
                           <a:cs typeface="Arial"/>
                         </a:rPr>
-                        <a:t>src/collect, src/clean, src/models; PRs #56, #57, #95, #96, #97; cards #5-#17, #23-#27, #43, #45</a:t>
+                        <a:t>src/collect, src/clean, src/models; PRs #56, #57, #95-#97; cards #5-#17, #23-#27, #43, #45, #83-#94</a:t>
                       </a:r>
                     </a:p>
                   </a:txBody>
@@ -17143,7 +17143,7 @@
                           <a:ea typeface="Arial"/>
                           <a:cs typeface="Arial"/>
                         </a:rPr>
-                        <a:t>0.404</a:t>
+                        <a:t>0.371</a:t>
                       </a:r>
                     </a:p>
                   </a:txBody>
@@ -17295,7 +17295,7 @@
                           <a:ea typeface="Arial"/>
                           <a:cs typeface="Arial"/>
                         </a:rPr>
-                        <a:t>0.421</a:t>
+                        <a:t>0.372</a:t>
                       </a:r>
                     </a:p>
                   </a:txBody>
@@ -17447,7 +17447,7 @@
                           <a:ea typeface="Arial"/>
                           <a:cs typeface="Arial"/>
                         </a:rPr>
-                        <a:t>0.388</a:t>
+                        <a:t>0.437</a:t>
                       </a:r>
                     </a:p>
                   </a:txBody>
@@ -17625,7 +17625,7 @@
                 <a:ea typeface="Arial"/>
                 <a:cs typeface="Arial"/>
               </a:rPr>
-              <a:t>the three tree models tie at review level (PR-AUC about 0.28 against 0.11 for guessing) and simple models match boosting at game level (about 0.42 against 0.22); store metadata says little about how good a game is. Game-level tuning is in progress.</a:t>
+              <a:t>the three tree models tie at review level (PR-AUC about 0.28 against 0.11 for guessing) and at game level tuned XGBoost (0.44) and Logistic Regression (0.42) lead, while Random Forest and LightGBM fall to 0.37 on test after tuning (intervals overlap, no winner); store metadata says little about how good a game is.</a:t>
             </a:r>
           </a:p>
         </p:txBody>

</xml_diff>

<commit_message>
Dashboard deployed at indieguard.streamlit.app: README, report, slides, docs
</commit_message>
<xml_diff>
--- a/slides/review2.pptx
+++ b/slides/review2.pptx
@@ -9624,7 +9624,7 @@
                 <a:ea typeface="Arial"/>
                 <a:cs typeface="Arial"/>
               </a:rPr>
-              <a:t>IndieGuard dashboard (Streamlit). Local launch: streamlit run src/dashboard/app.py; steps in docs/dashboard.md.</a:t>
+              <a:t>IndieGuard dashboard (Streamlit), live at https://indieguard.streamlit.app. Local launch: streamlit run src/dashboard/app.py; steps in docs/dashboard.md.</a:t>
             </a:r>
           </a:p>
         </p:txBody>
@@ -12676,7 +12676,7 @@
                 <a:ea typeface="Arial"/>
                 <a:cs typeface="Arial"/>
               </a:rPr>
-              <a:t>Units 1 to 3, evaluation, report and dashboard are implemented and integrated; the dashboard runs locally.</a:t>
+              <a:t>Units 1 to 3, evaluation, report and dashboard are implemented and integrated; the dashboard is deployed at indieguard.streamlit.app.</a:t>
             </a:r>
           </a:p>
         </p:txBody>

</xml_diff>

<commit_message>
Review 2 slides: show ROC-AUC next to PR-AUC for the text-mining evaluation
</commit_message>
<xml_diff>
--- a/slides/review2.pptx
+++ b/slides/review2.pptx
@@ -5252,7 +5252,7 @@
                 <a:ea typeface="Arial"/>
                 <a:cs typeface="Arial"/>
               </a:rPr>
-              <a:t>a negative-review detector (PR-AUC 0.84) and 8 complaint themes: crashes and multiplayer bugs lead early (29%), boss and balance later (34%); “boring” is in 9.1% of negative reviews against 0.8% of positive ones.</a:t>
+              <a:t>a negative-review detector (PR-AUC 0.84, ROC-AUC 0.97, accuracy 94.6%) and 8 complaint themes: crashes and multiplayer bugs lead early (29%), boss and balance later (34%); “boring” is in 9.1% of negative reviews against 0.8% of positive ones.</a:t>
             </a:r>
           </a:p>
         </p:txBody>
@@ -5508,9 +5508,9 @@
             <a:tbl>
               <a:tblPr/>
               <a:tblGrid>
-                <a:gridCol w="5120640"/>
-                <a:gridCol w="1828800"/>
-                <a:gridCol w="2194560"/>
+                <a:gridCol w="4389120"/>
+                <a:gridCol w="2651760"/>
+                <a:gridCol w="2103120"/>
                 <a:gridCol w="1828800"/>
               </a:tblGrid>
               <a:tr h="457200">
@@ -5576,7 +5576,7 @@
                           <a:ea typeface="Arial"/>
                           <a:cs typeface="Arial"/>
                         </a:rPr>
-                        <a:t>PR-AUC (test)</a:t>
+                        <a:t>PR-AUC / ROC-AUC (test)</a:t>
                       </a:r>
                     </a:p>
                   </a:txBody>
@@ -5746,7 +5746,7 @@
                           <a:ea typeface="Arial"/>
                           <a:cs typeface="Arial"/>
                         </a:rPr>
-                        <a:t>0.115</a:t>
+                        <a:t>0.115  /  0.500</a:t>
                       </a:r>
                     </a:p>
                   </a:txBody>
@@ -5898,7 +5898,7 @@
                           <a:ea typeface="Arial"/>
                           <a:cs typeface="Arial"/>
                         </a:rPr>
-                        <a:t>0.360</a:t>
+                        <a:t>0.360  /  0.758</a:t>
                       </a:r>
                     </a:p>
                   </a:txBody>
@@ -6050,7 +6050,7 @@
                           <a:ea typeface="Arial"/>
                           <a:cs typeface="Arial"/>
                         </a:rPr>
-                        <a:t>0.593</a:t>
+                        <a:t>0.593  /  0.895</a:t>
                       </a:r>
                     </a:p>
                   </a:txBody>
@@ -6202,7 +6202,7 @@
                           <a:ea typeface="Arial"/>
                           <a:cs typeface="Arial"/>
                         </a:rPr>
-                        <a:t>0.838</a:t>
+                        <a:t>0.838  /  0.971</a:t>
                       </a:r>
                     </a:p>
                   </a:txBody>
@@ -6452,7 +6452,7 @@
                 <a:ea typeface="Arial"/>
                 <a:cs typeface="Arial"/>
               </a:rPr>
-              <a:t>the full text model is selected: it detects a negative review far better than metadata. It detects, it does not forecast. A blind check of 200 reviews (labelled by an AI assistant) agrees with the topics on 35.5%: only the Early Access, repetition and crash topics are reliable.</a:t>
+              <a:t>the full text model is selected: ROC-AUC 0.971 (per-game 0.976) against 0.758 for metadata alone, and PR-AUC 0.838 against 0.360. It detects, it does not forecast. A blind check of 200 reviews (labelled by an AI assistant) agrees with the topics on 35.5%: only the Early Access, repetition and crash topics are reliable.</a:t>
             </a:r>
           </a:p>
         </p:txBody>

</xml_diff>

<commit_message>
Review 2 slides: bar chart slides for the model, text-mining and rule tables; update rehearsal timings
</commit_message>
<xml_diff>
--- a/slides/review2.pptx
+++ b/slides/review2.pptx
@@ -16,10 +16,13 @@
     <p:sldId xmlns:r="http://schemas.openxmlformats.org/officeDocument/2006/relationships" id="261" r:id="Rcdb49c028e314ea1"/>
     <p:sldId xmlns:r="http://schemas.openxmlformats.org/officeDocument/2006/relationships" id="262" r:id="R14c78c32adbc45b3"/>
     <p:sldId xmlns:r="http://schemas.openxmlformats.org/officeDocument/2006/relationships" id="263" r:id="Rb2ccc4eace8642f4"/>
+    <p:sldId xmlns:ns0="http://schemas.openxmlformats.org/officeDocument/2006/relationships" id="273" ns0:id="rId23"/>
     <p:sldId xmlns:r="http://schemas.openxmlformats.org/officeDocument/2006/relationships" id="264" r:id="R2432138f375d4f6f"/>
     <p:sldId xmlns:r="http://schemas.openxmlformats.org/officeDocument/2006/relationships" id="265" r:id="Rc5e53e3b48fb4bde"/>
+    <p:sldId xmlns:ns0="http://schemas.openxmlformats.org/officeDocument/2006/relationships" id="274" ns0:id="rId24"/>
     <p:sldId xmlns:r="http://schemas.openxmlformats.org/officeDocument/2006/relationships" id="266" r:id="Rda9f68c7d5914242"/>
     <p:sldId xmlns:r="http://schemas.openxmlformats.org/officeDocument/2006/relationships" id="267" r:id="R422860c0b274425a"/>
+    <p:sldId xmlns:ns0="http://schemas.openxmlformats.org/officeDocument/2006/relationships" id="275" ns0:id="rId25"/>
     <p:sldId xmlns:r="http://schemas.openxmlformats.org/officeDocument/2006/relationships" id="268" r:id="R7c0ae61b31f74095"/>
     <p:sldId xmlns:r="http://schemas.openxmlformats.org/officeDocument/2006/relationships" id="269" r:id="Ra78f76bec3d04acf"/>
     <p:sldId xmlns:r="http://schemas.openxmlformats.org/officeDocument/2006/relationships" id="270" r:id="R2e171858890a4a8a"/>
@@ -569,6 +572,1464 @@
       <c:valAx>
         <c:axId val="-2113994440"/>
         <c:scaling>
+          <c:min val="0.0"/>
+        </c:scaling>
+        <c:delete/>
+        <c:axPos val="l"/>
+        <c:majorTickMark val="out"/>
+        <c:minorTickMark val="none"/>
+        <c:tickLblPos val="nextTo"/>
+        <c:crossAx val="-2068027336"/>
+        <c:crosses val="autoZero"/>
+      </c:valAx>
+    </c:plotArea>
+    <c:dispBlanksAs val="gap"/>
+  </c:chart>
+  <c:txPr>
+    <a:bodyPr/>
+    <a:lstStyle/>
+    <a:p>
+      <a:pPr>
+        <a:defRPr sz="900">
+          <a:latin typeface="Arial"/>
+        </a:defRPr>
+      </a:pPr>
+      <a:endParaRPr lang="en-US"/>
+    </a:p>
+  </c:txPr>
+  <c:externalData r:id="rId1">
+    <c:autoUpdate val="0"/>
+  </c:externalData>
+</c:chartSpace>
+</file>
+
+<file path=ppt/charts/chart4.xml><?xml version="1.0" encoding="utf-8"?>
+<c:chartSpace xmlns:c="http://schemas.openxmlformats.org/drawingml/2006/chart" xmlns:a="http://schemas.openxmlformats.org/drawingml/2006/main" xmlns:r="http://schemas.openxmlformats.org/officeDocument/2006/relationships">
+  <c:date1904 val="0"/>
+  <c:chart>
+    <c:title>
+      <c:tx>
+        <c:rich>
+          <a:bodyPr/>
+          <a:lstStyle/>
+          <a:p>
+            <a:r>
+              <a:rPr sz="1200" b="1">
+                <a:solidFill>
+                  <a:srgbClr val="142D4E"/>
+                </a:solidFill>
+                <a:latin typeface="Arial"/>
+              </a:rPr>
+              <a:t>Review level (test): will a review be negative?</a:t>
+            </a:r>
+          </a:p>
+        </c:rich>
+      </c:tx>
+      <c:layout/>
+      <c:overlay val="0"/>
+    </c:title>
+    <c:autoTitleDeleted val="0"/>
+    <c:plotArea>
+      <c:barChart>
+        <c:barDir val="col"/>
+        <c:grouping val="clustered"/>
+        <c:ser>
+          <c:idx val="0"/>
+          <c:order val="0"/>
+          <c:tx>
+            <c:strRef>
+              <c:f>Sheet1!$B$1</c:f>
+              <c:strCache>
+                <c:ptCount val="1"/>
+                <c:pt idx="0">
+                  <c:v>PR-AUC</c:v>
+                </c:pt>
+              </c:strCache>
+            </c:strRef>
+          </c:tx>
+          <c:spPr>
+            <a:solidFill>
+              <a:srgbClr val="142D4E"/>
+            </a:solidFill>
+          </c:spPr>
+          <c:invertIfNegative val="0"/>
+          <c:cat>
+            <c:strRef>
+              <c:f>Sheet1!$A$2:$A$6</c:f>
+              <c:strCache>
+                <c:ptCount val="5"/>
+                <c:pt idx="0">
+                  <c:v>Dummy</c:v>
+                </c:pt>
+                <c:pt idx="1">
+                  <c:v>Logistic Reg.</c:v>
+                </c:pt>
+                <c:pt idx="2">
+                  <c:v>Random Forest</c:v>
+                </c:pt>
+                <c:pt idx="3">
+                  <c:v>LightGBM</c:v>
+                </c:pt>
+                <c:pt idx="4">
+                  <c:v>XGBoost</c:v>
+                </c:pt>
+              </c:strCache>
+            </c:strRef>
+          </c:cat>
+          <c:val>
+            <c:numRef>
+              <c:f>Sheet1!$B$2:$B$6</c:f>
+              <c:numCache>
+                <c:formatCode>General</c:formatCode>
+                <c:ptCount val="5"/>
+                <c:pt idx="0">
+                  <c:v>0.1063</c:v>
+                </c:pt>
+                <c:pt idx="1">
+                  <c:v>0.194</c:v>
+                </c:pt>
+                <c:pt idx="2">
+                  <c:v>0.2798</c:v>
+                </c:pt>
+                <c:pt idx="3">
+                  <c:v>0.2538</c:v>
+                </c:pt>
+                <c:pt idx="4">
+                  <c:v>0.2754</c:v>
+                </c:pt>
+              </c:numCache>
+            </c:numRef>
+          </c:val>
+        </c:ser>
+        <c:ser>
+          <c:idx val="1"/>
+          <c:order val="1"/>
+          <c:tx>
+            <c:strRef>
+              <c:f>Sheet1!$C$1</c:f>
+              <c:strCache>
+                <c:ptCount val="1"/>
+                <c:pt idx="0">
+                  <c:v>ROC-AUC</c:v>
+                </c:pt>
+              </c:strCache>
+            </c:strRef>
+          </c:tx>
+          <c:spPr>
+            <a:solidFill>
+              <a:srgbClr val="157A80"/>
+            </a:solidFill>
+          </c:spPr>
+          <c:invertIfNegative val="0"/>
+          <c:cat>
+            <c:strRef>
+              <c:f>Sheet1!$A$2:$A$6</c:f>
+              <c:strCache>
+                <c:ptCount val="5"/>
+                <c:pt idx="0">
+                  <c:v>Dummy</c:v>
+                </c:pt>
+                <c:pt idx="1">
+                  <c:v>Logistic Reg.</c:v>
+                </c:pt>
+                <c:pt idx="2">
+                  <c:v>Random Forest</c:v>
+                </c:pt>
+                <c:pt idx="3">
+                  <c:v>LightGBM</c:v>
+                </c:pt>
+                <c:pt idx="4">
+                  <c:v>XGBoost</c:v>
+                </c:pt>
+              </c:strCache>
+            </c:strRef>
+          </c:cat>
+          <c:val>
+            <c:numRef>
+              <c:f>Sheet1!$C$2:$C$6</c:f>
+              <c:numCache>
+                <c:formatCode>General</c:formatCode>
+                <c:ptCount val="5"/>
+                <c:pt idx="0">
+                  <c:v>0.5</c:v>
+                </c:pt>
+                <c:pt idx="1">
+                  <c:v>0.663</c:v>
+                </c:pt>
+                <c:pt idx="2">
+                  <c:v>0.726</c:v>
+                </c:pt>
+                <c:pt idx="3">
+                  <c:v>0.724</c:v>
+                </c:pt>
+                <c:pt idx="4">
+                  <c:v>0.729</c:v>
+                </c:pt>
+              </c:numCache>
+            </c:numRef>
+          </c:val>
+        </c:ser>
+        <c:dLbls>
+          <c:numFmt formatCode="0.00" sourceLinked="0"/>
+          <c:txPr>
+            <a:bodyPr/>
+            <a:lstStyle/>
+            <a:p>
+              <a:pPr>
+                <a:defRPr sz="1100"/>
+              </a:pPr>
+            </a:p>
+          </c:txPr>
+          <c:dLblPos val="outEnd"/>
+          <c:showLegendKey val="0"/>
+          <c:showVal val="1"/>
+          <c:showCatName val="0"/>
+          <c:showSerName val="0"/>
+          <c:showPercent val="0"/>
+          <c:showBubbleSize val="0"/>
+          <c:showLeaderLines val="1"/>
+        </c:dLbls>
+        <c:gapWidth val="55"/>
+        <c:axId val="-2068027336"/>
+        <c:axId val="-2113994440"/>
+      </c:barChart>
+      <c:catAx>
+        <c:axId val="-2068027336"/>
+        <c:scaling>
+          <c:orientation val="minMax"/>
+        </c:scaling>
+        <c:delete val="0"/>
+        <c:axPos val="b"/>
+        <c:majorTickMark val="out"/>
+        <c:minorTickMark val="none"/>
+        <c:tickLblPos val="nextTo"/>
+        <c:spPr>
+          <a:ln>
+            <a:solidFill>
+              <a:srgbClr val="C9D6E2"/>
+            </a:solidFill>
+          </a:ln>
+        </c:spPr>
+        <c:txPr>
+          <a:bodyPr/>
+          <a:lstStyle/>
+          <a:p>
+            <a:pPr>
+              <a:defRPr sz="1100"/>
+            </a:pPr>
+          </a:p>
+        </c:txPr>
+        <c:crossAx val="-2113994440"/>
+        <c:crosses val="autoZero"/>
+        <c:auto val="1"/>
+        <c:lblAlgn val="ctr"/>
+        <c:lblOffset val="100"/>
+        <c:noMultiLvlLbl val="0"/>
+      </c:catAx>
+      <c:valAx>
+        <c:axId val="-2113994440"/>
+        <c:scaling>
+          <c:max val="1.0"/>
+          <c:min val="0.0"/>
+        </c:scaling>
+        <c:delete/>
+        <c:axPos val="l"/>
+        <c:majorTickMark val="out"/>
+        <c:minorTickMark val="none"/>
+        <c:tickLblPos val="nextTo"/>
+        <c:crossAx val="-2068027336"/>
+        <c:crosses val="autoZero"/>
+      </c:valAx>
+    </c:plotArea>
+    <c:legend>
+      <c:legendPos val="b"/>
+      <c:overlay val="0"/>
+    </c:legend>
+    <c:dispBlanksAs val="gap"/>
+  </c:chart>
+  <c:txPr>
+    <a:bodyPr/>
+    <a:lstStyle/>
+    <a:p>
+      <a:pPr>
+        <a:defRPr sz="1100">
+          <a:latin typeface="Arial"/>
+        </a:defRPr>
+      </a:pPr>
+      <a:endParaRPr lang="en-US"/>
+    </a:p>
+  </c:txPr>
+  <c:externalData r:id="rId1">
+    <c:autoUpdate val="0"/>
+  </c:externalData>
+</c:chartSpace>
+</file>
+
+<file path=ppt/charts/chart5.xml><?xml version="1.0" encoding="utf-8"?>
+<c:chartSpace xmlns:c="http://schemas.openxmlformats.org/drawingml/2006/chart" xmlns:a="http://schemas.openxmlformats.org/drawingml/2006/main" xmlns:r="http://schemas.openxmlformats.org/officeDocument/2006/relationships">
+  <c:date1904 val="0"/>
+  <c:chart>
+    <c:title>
+      <c:tx>
+        <c:rich>
+          <a:bodyPr/>
+          <a:lstStyle/>
+          <a:p>
+            <a:r>
+              <a:rPr sz="1200" b="1">
+                <a:solidFill>
+                  <a:srgbClr val="142D4E"/>
+                </a:solidFill>
+                <a:latin typeface="Arial"/>
+              </a:rPr>
+              <a:t>Game level (test): success tier</a:t>
+            </a:r>
+          </a:p>
+        </c:rich>
+      </c:tx>
+      <c:layout/>
+      <c:overlay val="0"/>
+    </c:title>
+    <c:autoTitleDeleted val="0"/>
+    <c:plotArea>
+      <c:barChart>
+        <c:barDir val="col"/>
+        <c:grouping val="clustered"/>
+        <c:ser>
+          <c:idx val="0"/>
+          <c:order val="0"/>
+          <c:tx>
+            <c:strRef>
+              <c:f>Sheet1!$B$1</c:f>
+              <c:strCache>
+                <c:ptCount val="1"/>
+                <c:pt idx="0">
+                  <c:v>macro-F1</c:v>
+                </c:pt>
+              </c:strCache>
+            </c:strRef>
+          </c:tx>
+          <c:spPr>
+            <a:solidFill>
+              <a:srgbClr val="C44E52"/>
+            </a:solidFill>
+          </c:spPr>
+          <c:invertIfNegative val="0"/>
+          <c:cat>
+            <c:strRef>
+              <c:f>Sheet1!$A$2:$A$6</c:f>
+              <c:strCache>
+                <c:ptCount val="5"/>
+                <c:pt idx="0">
+                  <c:v>Dummy</c:v>
+                </c:pt>
+                <c:pt idx="1">
+                  <c:v>Logistic Reg.</c:v>
+                </c:pt>
+                <c:pt idx="2">
+                  <c:v>Random Forest</c:v>
+                </c:pt>
+                <c:pt idx="3">
+                  <c:v>LightGBM</c:v>
+                </c:pt>
+                <c:pt idx="4">
+                  <c:v>XGBoost</c:v>
+                </c:pt>
+              </c:strCache>
+            </c:strRef>
+          </c:cat>
+          <c:val>
+            <c:numRef>
+              <c:f>Sheet1!$B$2:$B$6</c:f>
+              <c:numCache>
+                <c:formatCode>General</c:formatCode>
+                <c:ptCount val="5"/>
+                <c:pt idx="0">
+                  <c:v>0.2197</c:v>
+                </c:pt>
+                <c:pt idx="1">
+                  <c:v>0.4233</c:v>
+                </c:pt>
+                <c:pt idx="2">
+                  <c:v>0.3708</c:v>
+                </c:pt>
+                <c:pt idx="3">
+                  <c:v>0.3717</c:v>
+                </c:pt>
+                <c:pt idx="4">
+                  <c:v>0.4374</c:v>
+                </c:pt>
+              </c:numCache>
+            </c:numRef>
+          </c:val>
+        </c:ser>
+        <c:dLbls>
+          <c:numFmt formatCode="0.00" sourceLinked="0"/>
+          <c:txPr>
+            <a:bodyPr/>
+            <a:lstStyle/>
+            <a:p>
+              <a:pPr>
+                <a:defRPr sz="1100"/>
+              </a:pPr>
+            </a:p>
+          </c:txPr>
+          <c:dLblPos val="outEnd"/>
+          <c:showLegendKey val="0"/>
+          <c:showVal val="1"/>
+          <c:showCatName val="0"/>
+          <c:showSerName val="0"/>
+          <c:showPercent val="0"/>
+          <c:showBubbleSize val="0"/>
+          <c:showLeaderLines val="1"/>
+        </c:dLbls>
+        <c:gapWidth val="55"/>
+        <c:axId val="-2068027336"/>
+        <c:axId val="-2113994440"/>
+      </c:barChart>
+      <c:catAx>
+        <c:axId val="-2068027336"/>
+        <c:scaling>
+          <c:orientation val="minMax"/>
+        </c:scaling>
+        <c:delete val="0"/>
+        <c:axPos val="b"/>
+        <c:majorTickMark val="out"/>
+        <c:minorTickMark val="none"/>
+        <c:tickLblPos val="nextTo"/>
+        <c:spPr>
+          <a:ln>
+            <a:solidFill>
+              <a:srgbClr val="C9D6E2"/>
+            </a:solidFill>
+          </a:ln>
+        </c:spPr>
+        <c:txPr>
+          <a:bodyPr/>
+          <a:lstStyle/>
+          <a:p>
+            <a:pPr>
+              <a:defRPr sz="1100"/>
+            </a:pPr>
+          </a:p>
+        </c:txPr>
+        <c:crossAx val="-2113994440"/>
+        <c:crosses val="autoZero"/>
+        <c:auto val="1"/>
+        <c:lblAlgn val="ctr"/>
+        <c:lblOffset val="100"/>
+        <c:noMultiLvlLbl val="0"/>
+      </c:catAx>
+      <c:valAx>
+        <c:axId val="-2113994440"/>
+        <c:scaling>
+          <c:max val="0.6"/>
+          <c:min val="0.0"/>
+        </c:scaling>
+        <c:delete/>
+        <c:axPos val="l"/>
+        <c:majorTickMark val="out"/>
+        <c:minorTickMark val="none"/>
+        <c:tickLblPos val="nextTo"/>
+        <c:crossAx val="-2068027336"/>
+        <c:crosses val="autoZero"/>
+      </c:valAx>
+    </c:plotArea>
+    <c:dispBlanksAs val="gap"/>
+  </c:chart>
+  <c:txPr>
+    <a:bodyPr/>
+    <a:lstStyle/>
+    <a:p>
+      <a:pPr>
+        <a:defRPr sz="1100">
+          <a:latin typeface="Arial"/>
+        </a:defRPr>
+      </a:pPr>
+      <a:endParaRPr lang="en-US"/>
+    </a:p>
+  </c:txPr>
+  <c:externalData r:id="rId1">
+    <c:autoUpdate val="0"/>
+  </c:externalData>
+</c:chartSpace>
+</file>
+
+<file path=ppt/charts/chart6.xml><?xml version="1.0" encoding="utf-8"?>
+<c:chartSpace xmlns:c="http://schemas.openxmlformats.org/drawingml/2006/chart" xmlns:a="http://schemas.openxmlformats.org/drawingml/2006/main" xmlns:r="http://schemas.openxmlformats.org/officeDocument/2006/relationships">
+  <c:date1904 val="0"/>
+  <c:chart>
+    <c:title>
+      <c:tx>
+        <c:rich>
+          <a:bodyPr/>
+          <a:lstStyle/>
+          <a:p>
+            <a:r>
+              <a:rPr sz="1200" b="1">
+                <a:solidFill>
+                  <a:srgbClr val="142D4E"/>
+                </a:solidFill>
+                <a:latin typeface="Arial"/>
+              </a:rPr>
+              <a:t>Does the review text help? (test, English reviews)</a:t>
+            </a:r>
+          </a:p>
+        </c:rich>
+      </c:tx>
+      <c:layout/>
+      <c:overlay val="0"/>
+    </c:title>
+    <c:autoTitleDeleted val="0"/>
+    <c:plotArea>
+      <c:barChart>
+        <c:barDir val="col"/>
+        <c:grouping val="clustered"/>
+        <c:ser>
+          <c:idx val="0"/>
+          <c:order val="0"/>
+          <c:tx>
+            <c:strRef>
+              <c:f>Sheet1!$B$1</c:f>
+              <c:strCache>
+                <c:ptCount val="1"/>
+                <c:pt idx="0">
+                  <c:v>PR-AUC</c:v>
+                </c:pt>
+              </c:strCache>
+            </c:strRef>
+          </c:tx>
+          <c:spPr>
+            <a:solidFill>
+              <a:srgbClr val="142D4E"/>
+            </a:solidFill>
+          </c:spPr>
+          <c:invertIfNegative val="0"/>
+          <c:cat>
+            <c:strRef>
+              <c:f>Sheet1!$A$2:$A$5</c:f>
+              <c:strCache>
+                <c:ptCount val="4"/>
+                <c:pt idx="0">
+                  <c:v>Dummy</c:v>
+                </c:pt>
+                <c:pt idx="1">
+                  <c:v>LightGBM, metadata</c:v>
+                </c:pt>
+                <c:pt idx="2">
+                  <c:v>LightGBM + text components</c:v>
+                </c:pt>
+                <c:pt idx="3">
+                  <c:v>Logistic Reg., full text</c:v>
+                </c:pt>
+              </c:strCache>
+            </c:strRef>
+          </c:cat>
+          <c:val>
+            <c:numRef>
+              <c:f>Sheet1!$B$2:$B$5</c:f>
+              <c:numCache>
+                <c:formatCode>General</c:formatCode>
+                <c:ptCount val="4"/>
+                <c:pt idx="0">
+                  <c:v>0.1151</c:v>
+                </c:pt>
+                <c:pt idx="1">
+                  <c:v>0.3605</c:v>
+                </c:pt>
+                <c:pt idx="2">
+                  <c:v>0.5934</c:v>
+                </c:pt>
+                <c:pt idx="3">
+                  <c:v>0.8378</c:v>
+                </c:pt>
+              </c:numCache>
+            </c:numRef>
+          </c:val>
+        </c:ser>
+        <c:ser>
+          <c:idx val="1"/>
+          <c:order val="1"/>
+          <c:tx>
+            <c:strRef>
+              <c:f>Sheet1!$C$1</c:f>
+              <c:strCache>
+                <c:ptCount val="1"/>
+                <c:pt idx="0">
+                  <c:v>ROC-AUC</c:v>
+                </c:pt>
+              </c:strCache>
+            </c:strRef>
+          </c:tx>
+          <c:spPr>
+            <a:solidFill>
+              <a:srgbClr val="157A80"/>
+            </a:solidFill>
+          </c:spPr>
+          <c:invertIfNegative val="0"/>
+          <c:cat>
+            <c:strRef>
+              <c:f>Sheet1!$A$2:$A$5</c:f>
+              <c:strCache>
+                <c:ptCount val="4"/>
+                <c:pt idx="0">
+                  <c:v>Dummy</c:v>
+                </c:pt>
+                <c:pt idx="1">
+                  <c:v>LightGBM, metadata</c:v>
+                </c:pt>
+                <c:pt idx="2">
+                  <c:v>LightGBM + text components</c:v>
+                </c:pt>
+                <c:pt idx="3">
+                  <c:v>Logistic Reg., full text</c:v>
+                </c:pt>
+              </c:strCache>
+            </c:strRef>
+          </c:cat>
+          <c:val>
+            <c:numRef>
+              <c:f>Sheet1!$C$2:$C$5</c:f>
+              <c:numCache>
+                <c:formatCode>General</c:formatCode>
+                <c:ptCount val="4"/>
+                <c:pt idx="0">
+                  <c:v>0.5</c:v>
+                </c:pt>
+                <c:pt idx="1">
+                  <c:v>0.758</c:v>
+                </c:pt>
+                <c:pt idx="2">
+                  <c:v>0.895</c:v>
+                </c:pt>
+                <c:pt idx="3">
+                  <c:v>0.971</c:v>
+                </c:pt>
+              </c:numCache>
+            </c:numRef>
+          </c:val>
+        </c:ser>
+        <c:dLbls>
+          <c:numFmt formatCode="0.00" sourceLinked="0"/>
+          <c:txPr>
+            <a:bodyPr/>
+            <a:lstStyle/>
+            <a:p>
+              <a:pPr>
+                <a:defRPr sz="1100"/>
+              </a:pPr>
+            </a:p>
+          </c:txPr>
+          <c:dLblPos val="outEnd"/>
+          <c:showLegendKey val="0"/>
+          <c:showVal val="1"/>
+          <c:showCatName val="0"/>
+          <c:showSerName val="0"/>
+          <c:showPercent val="0"/>
+          <c:showBubbleSize val="0"/>
+          <c:showLeaderLines val="1"/>
+        </c:dLbls>
+        <c:gapWidth val="55"/>
+        <c:axId val="-2068027336"/>
+        <c:axId val="-2113994440"/>
+      </c:barChart>
+      <c:catAx>
+        <c:axId val="-2068027336"/>
+        <c:scaling>
+          <c:orientation val="minMax"/>
+        </c:scaling>
+        <c:delete val="0"/>
+        <c:axPos val="b"/>
+        <c:majorTickMark val="out"/>
+        <c:minorTickMark val="none"/>
+        <c:tickLblPos val="nextTo"/>
+        <c:spPr>
+          <a:ln>
+            <a:solidFill>
+              <a:srgbClr val="C9D6E2"/>
+            </a:solidFill>
+          </a:ln>
+        </c:spPr>
+        <c:txPr>
+          <a:bodyPr/>
+          <a:lstStyle/>
+          <a:p>
+            <a:pPr>
+              <a:defRPr sz="1100"/>
+            </a:pPr>
+          </a:p>
+        </c:txPr>
+        <c:crossAx val="-2113994440"/>
+        <c:crosses val="autoZero"/>
+        <c:auto val="1"/>
+        <c:lblAlgn val="ctr"/>
+        <c:lblOffset val="100"/>
+        <c:noMultiLvlLbl val="0"/>
+      </c:catAx>
+      <c:valAx>
+        <c:axId val="-2113994440"/>
+        <c:scaling>
+          <c:max val="1.15"/>
+          <c:min val="0.0"/>
+        </c:scaling>
+        <c:delete/>
+        <c:axPos val="l"/>
+        <c:majorTickMark val="out"/>
+        <c:minorTickMark val="none"/>
+        <c:tickLblPos val="nextTo"/>
+        <c:crossAx val="-2068027336"/>
+        <c:crosses val="autoZero"/>
+      </c:valAx>
+    </c:plotArea>
+    <c:legend>
+      <c:legendPos val="b"/>
+      <c:overlay val="0"/>
+    </c:legend>
+    <c:dispBlanksAs val="gap"/>
+  </c:chart>
+  <c:txPr>
+    <a:bodyPr/>
+    <a:lstStyle/>
+    <a:p>
+      <a:pPr>
+        <a:defRPr sz="1100">
+          <a:latin typeface="Arial"/>
+        </a:defRPr>
+      </a:pPr>
+      <a:endParaRPr lang="en-US"/>
+    </a:p>
+  </c:txPr>
+  <c:externalData r:id="rId1">
+    <c:autoUpdate val="0"/>
+  </c:externalData>
+</c:chartSpace>
+</file>
+
+<file path=ppt/charts/chart7.xml><?xml version="1.0" encoding="utf-8"?>
+<c:chartSpace xmlns:c="http://schemas.openxmlformats.org/drawingml/2006/chart" xmlns:a="http://schemas.openxmlformats.org/drawingml/2006/main" xmlns:r="http://schemas.openxmlformats.org/officeDocument/2006/relationships">
+  <c:date1904 val="0"/>
+  <c:chart>
+    <c:title>
+      <c:tx>
+        <c:rich>
+          <a:bodyPr/>
+          <a:lstStyle/>
+          <a:p>
+            <a:r>
+              <a:rPr sz="1100" b="1">
+                <a:solidFill>
+                  <a:srgbClr val="142D4E"/>
+                </a:solidFill>
+                <a:latin typeface="Arial"/>
+              </a:rPr>
+              <a:t>Main complaint theme of negative reviews (%)</a:t>
+            </a:r>
+          </a:p>
+        </c:rich>
+      </c:tx>
+      <c:layout/>
+      <c:overlay val="0"/>
+    </c:title>
+    <c:autoTitleDeleted val="0"/>
+    <c:plotArea>
+      <c:barChart>
+        <c:barDir val="col"/>
+        <c:grouping val="clustered"/>
+        <c:ser>
+          <c:idx val="0"/>
+          <c:order val="0"/>
+          <c:tx>
+            <c:strRef>
+              <c:f>Sheet1!$B$1</c:f>
+              <c:strCache>
+                <c:ptCount val="1"/>
+                <c:pt idx="0">
+                  <c:v>under 2 h</c:v>
+                </c:pt>
+              </c:strCache>
+            </c:strRef>
+          </c:tx>
+          <c:spPr>
+            <a:solidFill>
+              <a:srgbClr val="C44E52"/>
+            </a:solidFill>
+          </c:spPr>
+          <c:invertIfNegative val="0"/>
+          <c:cat>
+            <c:strRef>
+              <c:f>Sheet1!$A$2:$A$6</c:f>
+              <c:strCache>
+                <c:ptCount val="5"/>
+                <c:pt idx="0">
+                  <c:v>Multiplayer, crashes</c:v>
+                </c:pt>
+                <c:pt idx="1">
+                  <c:v>Boss and difficulty</c:v>
+                </c:pt>
+                <c:pt idx="2">
+                  <c:v>Art vs gameplay loop</c:v>
+                </c:pt>
+                <c:pt idx="3">
+                  <c:v>Replayability, co-op</c:v>
+                </c:pt>
+                <c:pt idx="4">
+                  <c:v>Repetitive, grind</c:v>
+                </c:pt>
+              </c:strCache>
+            </c:strRef>
+          </c:cat>
+          <c:val>
+            <c:numRef>
+              <c:f>Sheet1!$B$2:$B$6</c:f>
+              <c:numCache>
+                <c:formatCode>General</c:formatCode>
+                <c:ptCount val="5"/>
+                <c:pt idx="0">
+                  <c:v>28.668791909420687</c:v>
+                </c:pt>
+                <c:pt idx="1">
+                  <c:v>25.14015609541607</c:v>
+                </c:pt>
+                <c:pt idx="2">
+                  <c:v>22.2381004726833</c:v>
+                </c:pt>
+                <c:pt idx="3">
+                  <c:v>7.35407277124326</c:v>
+                </c:pt>
+                <c:pt idx="4">
+                  <c:v>5.67219962625041</c:v>
+                </c:pt>
+              </c:numCache>
+            </c:numRef>
+          </c:val>
+        </c:ser>
+        <c:ser>
+          <c:idx val="1"/>
+          <c:order val="1"/>
+          <c:tx>
+            <c:strRef>
+              <c:f>Sheet1!$C$1</c:f>
+              <c:strCache>
+                <c:ptCount val="1"/>
+                <c:pt idx="0">
+                  <c:v>2 h or more</c:v>
+                </c:pt>
+              </c:strCache>
+            </c:strRef>
+          </c:tx>
+          <c:spPr>
+            <a:solidFill>
+              <a:srgbClr val="8C99A6"/>
+            </a:solidFill>
+          </c:spPr>
+          <c:invertIfNegative val="0"/>
+          <c:cat>
+            <c:strRef>
+              <c:f>Sheet1!$A$2:$A$6</c:f>
+              <c:strCache>
+                <c:ptCount val="5"/>
+                <c:pt idx="0">
+                  <c:v>Multiplayer, crashes</c:v>
+                </c:pt>
+                <c:pt idx="1">
+                  <c:v>Boss and difficulty</c:v>
+                </c:pt>
+                <c:pt idx="2">
+                  <c:v>Art vs gameplay loop</c:v>
+                </c:pt>
+                <c:pt idx="3">
+                  <c:v>Replayability, co-op</c:v>
+                </c:pt>
+                <c:pt idx="4">
+                  <c:v>Repetitive, grind</c:v>
+                </c:pt>
+              </c:strCache>
+            </c:strRef>
+          </c:cat>
+          <c:val>
+            <c:numRef>
+              <c:f>Sheet1!$C$2:$C$6</c:f>
+              <c:numCache>
+                <c:formatCode>General</c:formatCode>
+                <c:ptCount val="5"/>
+                <c:pt idx="0">
+                  <c:v>23.52386342199585</c:v>
+                </c:pt>
+                <c:pt idx="1">
+                  <c:v>34.12563667232597</c:v>
+                </c:pt>
+                <c:pt idx="2">
+                  <c:v>17.688486449097653</c:v>
+                </c:pt>
+                <c:pt idx="3">
+                  <c:v>10.46972269383135</c:v>
+                </c:pt>
+                <c:pt idx="4">
+                  <c:v>4.04955039929573</c:v>
+                </c:pt>
+              </c:numCache>
+            </c:numRef>
+          </c:val>
+        </c:ser>
+        <c:dLbls>
+          <c:numFmt formatCode="0&quot;%&quot;" sourceLinked="0"/>
+          <c:txPr>
+            <a:bodyPr/>
+            <a:lstStyle/>
+            <a:p>
+              <a:pPr>
+                <a:defRPr sz="1000"/>
+              </a:pPr>
+            </a:p>
+          </c:txPr>
+          <c:dLblPos val="outEnd"/>
+          <c:showLegendKey val="0"/>
+          <c:showVal val="1"/>
+          <c:showCatName val="0"/>
+          <c:showSerName val="0"/>
+          <c:showPercent val="0"/>
+          <c:showBubbleSize val="0"/>
+          <c:showLeaderLines val="1"/>
+        </c:dLbls>
+        <c:gapWidth val="55"/>
+        <c:axId val="-2068027336"/>
+        <c:axId val="-2113994440"/>
+      </c:barChart>
+      <c:catAx>
+        <c:axId val="-2068027336"/>
+        <c:scaling>
+          <c:orientation val="minMax"/>
+        </c:scaling>
+        <c:delete val="0"/>
+        <c:axPos val="b"/>
+        <c:majorTickMark val="out"/>
+        <c:minorTickMark val="none"/>
+        <c:tickLblPos val="nextTo"/>
+        <c:spPr>
+          <a:ln>
+            <a:solidFill>
+              <a:srgbClr val="C9D6E2"/>
+            </a:solidFill>
+          </a:ln>
+        </c:spPr>
+        <c:txPr>
+          <a:bodyPr/>
+          <a:lstStyle/>
+          <a:p>
+            <a:pPr>
+              <a:defRPr sz="1000"/>
+            </a:pPr>
+          </a:p>
+        </c:txPr>
+        <c:crossAx val="-2113994440"/>
+        <c:crosses val="autoZero"/>
+        <c:auto val="1"/>
+        <c:lblAlgn val="ctr"/>
+        <c:lblOffset val="100"/>
+        <c:noMultiLvlLbl val="0"/>
+      </c:catAx>
+      <c:valAx>
+        <c:axId val="-2113994440"/>
+        <c:scaling>
+          <c:max val="45.0"/>
+          <c:min val="0.0"/>
+        </c:scaling>
+        <c:delete/>
+        <c:axPos val="l"/>
+        <c:majorTickMark val="out"/>
+        <c:minorTickMark val="none"/>
+        <c:tickLblPos val="nextTo"/>
+        <c:crossAx val="-2068027336"/>
+        <c:crosses val="autoZero"/>
+      </c:valAx>
+    </c:plotArea>
+    <c:legend>
+      <c:legendPos val="b"/>
+      <c:overlay val="0"/>
+    </c:legend>
+    <c:dispBlanksAs val="gap"/>
+  </c:chart>
+  <c:txPr>
+    <a:bodyPr/>
+    <a:lstStyle/>
+    <a:p>
+      <a:pPr>
+        <a:defRPr sz="1000">
+          <a:latin typeface="Arial"/>
+        </a:defRPr>
+      </a:pPr>
+      <a:endParaRPr lang="en-US"/>
+    </a:p>
+  </c:txPr>
+  <c:externalData r:id="rId1">
+    <c:autoUpdate val="0"/>
+  </c:externalData>
+</c:chartSpace>
+</file>
+
+<file path=ppt/charts/chart8.xml><?xml version="1.0" encoding="utf-8"?>
+<c:chartSpace xmlns:c="http://schemas.openxmlformats.org/drawingml/2006/chart" xmlns:a="http://schemas.openxmlformats.org/drawingml/2006/main" xmlns:r="http://schemas.openxmlformats.org/officeDocument/2006/relationships">
+  <c:date1904 val="0"/>
+  <c:chart>
+    <c:title>
+      <c:tx>
+        <c:rich>
+          <a:bodyPr/>
+          <a:lstStyle/>
+          <a:p>
+            <a:r>
+              <a:rPr sz="1000" b="1">
+                <a:solidFill>
+                  <a:srgbClr val="142D4E"/>
+                </a:solidFill>
+                <a:latin typeface="Arial"/>
+              </a:rPr>
+              <a:t>Top 8 Strong rules by lift: share of games in the Strong tier (%)</a:t>
+            </a:r>
+          </a:p>
+        </c:rich>
+      </c:tx>
+      <c:layout/>
+      <c:overlay val="0"/>
+    </c:title>
+    <c:autoTitleDeleted val="0"/>
+    <c:plotArea>
+      <c:barChart>
+        <c:barDir val="bar"/>
+        <c:grouping val="clustered"/>
+        <c:ser>
+          <c:idx val="0"/>
+          <c:order val="0"/>
+          <c:tx>
+            <c:strRef>
+              <c:f>Sheet1!$B$1</c:f>
+              <c:strCache>
+                <c:ptCount val="1"/>
+                <c:pt idx="0">
+                  <c:v>training games</c:v>
+                </c:pt>
+              </c:strCache>
+            </c:strRef>
+          </c:tx>
+          <c:spPr>
+            <a:solidFill>
+              <a:srgbClr val="142D4E"/>
+            </a:solidFill>
+          </c:spPr>
+          <c:invertIfNegative val="0"/>
+          <c:cat>
+            <c:strRef>
+              <c:f>Sheet1!$A$2:$A$9</c:f>
+              <c:strCache>
+                <c:ptCount val="8"/>
+                <c:pt idx="0">
+                  <c:v>Pixel Graphics + Retro + Shooter</c:v>
+                </c:pt>
+                <c:pt idx="1">
+                  <c:v>Pixel Graphics + Puzzle</c:v>
+                </c:pt>
+                <c:pt idx="2">
+                  <c:v>2D + Bullet Hell + Procedural Generation</c:v>
+                </c:pt>
+                <c:pt idx="3">
+                  <c:v>Retro + Shooter</c:v>
+                </c:pt>
+                <c:pt idx="4">
+                  <c:v>Procedural Generation + Retro</c:v>
+                </c:pt>
+                <c:pt idx="5">
+                  <c:v>Arcade + Retro + Roguelite</c:v>
+                </c:pt>
+                <c:pt idx="6">
+                  <c:v>price &lt;$5 + Retro + Roguelite</c:v>
+                </c:pt>
+                <c:pt idx="7">
+                  <c:v>price &lt;$5 + Action Roguelike + Procedural Generation</c:v>
+                </c:pt>
+              </c:strCache>
+            </c:strRef>
+          </c:cat>
+          <c:val>
+            <c:numRef>
+              <c:f>Sheet1!$B$2:$B$9</c:f>
+              <c:numCache>
+                <c:formatCode>General</c:formatCode>
+                <c:ptCount val="8"/>
+                <c:pt idx="0">
+                  <c:v>80.0</c:v>
+                </c:pt>
+                <c:pt idx="1">
+                  <c:v>76.92307692307693</c:v>
+                </c:pt>
+                <c:pt idx="2">
+                  <c:v>72.41379310344827</c:v>
+                </c:pt>
+                <c:pt idx="3">
+                  <c:v>71.42857142857143</c:v>
+                </c:pt>
+                <c:pt idx="4">
+                  <c:v>67.44186046511628</c:v>
+                </c:pt>
+                <c:pt idx="5">
+                  <c:v>67.3076923076923</c:v>
+                </c:pt>
+                <c:pt idx="6">
+                  <c:v>66.66666666666666</c:v>
+                </c:pt>
+                <c:pt idx="7">
+                  <c:v>66.66666666666666</c:v>
+                </c:pt>
+              </c:numCache>
+            </c:numRef>
+          </c:val>
+        </c:ser>
+        <c:ser>
+          <c:idx val="1"/>
+          <c:order val="1"/>
+          <c:tx>
+            <c:strRef>
+              <c:f>Sheet1!$C$1</c:f>
+              <c:strCache>
+                <c:ptCount val="1"/>
+                <c:pt idx="0">
+                  <c:v>test games</c:v>
+                </c:pt>
+              </c:strCache>
+            </c:strRef>
+          </c:tx>
+          <c:spPr>
+            <a:solidFill>
+              <a:srgbClr val="C44E52"/>
+            </a:solidFill>
+          </c:spPr>
+          <c:invertIfNegative val="0"/>
+          <c:cat>
+            <c:strRef>
+              <c:f>Sheet1!$A$2:$A$9</c:f>
+              <c:strCache>
+                <c:ptCount val="8"/>
+                <c:pt idx="0">
+                  <c:v>Pixel Graphics + Retro + Shooter</c:v>
+                </c:pt>
+                <c:pt idx="1">
+                  <c:v>Pixel Graphics + Puzzle</c:v>
+                </c:pt>
+                <c:pt idx="2">
+                  <c:v>2D + Bullet Hell + Procedural Generation</c:v>
+                </c:pt>
+                <c:pt idx="3">
+                  <c:v>Retro + Shooter</c:v>
+                </c:pt>
+                <c:pt idx="4">
+                  <c:v>Procedural Generation + Retro</c:v>
+                </c:pt>
+                <c:pt idx="5">
+                  <c:v>Arcade + Retro + Roguelite</c:v>
+                </c:pt>
+                <c:pt idx="6">
+                  <c:v>price &lt;$5 + Retro + Roguelite</c:v>
+                </c:pt>
+                <c:pt idx="7">
+                  <c:v>price &lt;$5 + Action Roguelike + Procedural Generation</c:v>
+                </c:pt>
+              </c:strCache>
+            </c:strRef>
+          </c:cat>
+          <c:val>
+            <c:numRef>
+              <c:f>Sheet1!$C$2:$C$9</c:f>
+              <c:numCache>
+                <c:formatCode>General</c:formatCode>
+                <c:ptCount val="8"/>
+                <c:pt idx="0">
+                  <c:v>75.0</c:v>
+                </c:pt>
+                <c:pt idx="1">
+                  <c:v>62.5</c:v>
+                </c:pt>
+                <c:pt idx="2">
+                  <c:v>27.27272727272727</c:v>
+                </c:pt>
+                <c:pt idx="3">
+                  <c:v>50.0</c:v>
+                </c:pt>
+                <c:pt idx="4">
+                  <c:v>57.14285714285714</c:v>
+                </c:pt>
+                <c:pt idx="5">
+                  <c:v>54.54545454545454</c:v>
+                </c:pt>
+                <c:pt idx="6">
+                  <c:v>28.57142857142857</c:v>
+                </c:pt>
+                <c:pt idx="7">
+                  <c:v>36.36363636363636</c:v>
+                </c:pt>
+              </c:numCache>
+            </c:numRef>
+          </c:val>
+        </c:ser>
+        <c:dLbls>
+          <c:numFmt formatCode="0&quot;%&quot;" sourceLinked="0"/>
+          <c:txPr>
+            <a:bodyPr/>
+            <a:lstStyle/>
+            <a:p>
+              <a:pPr>
+                <a:defRPr sz="900"/>
+              </a:pPr>
+            </a:p>
+          </c:txPr>
+          <c:dLblPos val="outEnd"/>
+          <c:showLegendKey val="0"/>
+          <c:showVal val="1"/>
+          <c:showCatName val="0"/>
+          <c:showSerName val="0"/>
+          <c:showPercent val="0"/>
+          <c:showBubbleSize val="0"/>
+          <c:showLeaderLines val="1"/>
+        </c:dLbls>
+        <c:gapWidth val="55"/>
+        <c:axId val="-2068027336"/>
+        <c:axId val="-2113994440"/>
+      </c:barChart>
+      <c:catAx>
+        <c:axId val="-2068027336"/>
+        <c:scaling>
+          <c:orientation val="maxMin"/>
+        </c:scaling>
+        <c:delete val="0"/>
+        <c:axPos val="l"/>
+        <c:majorTickMark val="out"/>
+        <c:minorTickMark val="none"/>
+        <c:tickLblPos val="nextTo"/>
+        <c:spPr>
+          <a:ln>
+            <a:solidFill>
+              <a:srgbClr val="C9D6E2"/>
+            </a:solidFill>
+          </a:ln>
+        </c:spPr>
+        <c:txPr>
+          <a:bodyPr/>
+          <a:lstStyle/>
+          <a:p>
+            <a:pPr>
+              <a:defRPr sz="900"/>
+            </a:pPr>
+          </a:p>
+        </c:txPr>
+        <c:crossAx val="-2113994440"/>
+        <c:crosses val="autoZero"/>
+        <c:auto val="1"/>
+        <c:lblAlgn val="ctr"/>
+        <c:lblOffset val="100"/>
+        <c:noMultiLvlLbl val="0"/>
+      </c:catAx>
+      <c:valAx>
+        <c:axId val="-2113994440"/>
+        <c:scaling>
+          <c:max val="100.0"/>
+          <c:min val="0.0"/>
+        </c:scaling>
+        <c:delete/>
+        <c:axPos val="b"/>
+        <c:majorTickMark val="out"/>
+        <c:minorTickMark val="none"/>
+        <c:tickLblPos val="nextTo"/>
+        <c:crossAx val="-2068027336"/>
+        <c:crosses val="autoZero"/>
+      </c:valAx>
+    </c:plotArea>
+    <c:legend>
+      <c:legendPos val="b"/>
+      <c:overlay val="0"/>
+    </c:legend>
+    <c:dispBlanksAs val="gap"/>
+  </c:chart>
+  <c:txPr>
+    <a:bodyPr/>
+    <a:lstStyle/>
+    <a:p>
+      <a:pPr>
+        <a:defRPr sz="900">
+          <a:latin typeface="Arial"/>
+        </a:defRPr>
+      </a:pPr>
+      <a:endParaRPr lang="en-US"/>
+    </a:p>
+  </c:txPr>
+  <c:externalData r:id="rId1">
+    <c:autoUpdate val="0"/>
+  </c:externalData>
+</c:chartSpace>
+</file>
+
+<file path=ppt/charts/chart9.xml><?xml version="1.0" encoding="utf-8"?>
+<c:chartSpace xmlns:c="http://schemas.openxmlformats.org/drawingml/2006/chart" xmlns:a="http://schemas.openxmlformats.org/drawingml/2006/main" xmlns:r="http://schemas.openxmlformats.org/officeDocument/2006/relationships">
+  <c:date1904 val="0"/>
+  <c:chart>
+    <c:title>
+      <c:tx>
+        <c:rich>
+          <a:bodyPr/>
+          <a:lstStyle/>
+          <a:p>
+            <a:r>
+              <a:rPr sz="1000" b="1">
+                <a:solidFill>
+                  <a:srgbClr val="142D4E"/>
+                </a:solidFill>
+                <a:latin typeface="Arial"/>
+              </a:rPr>
+              <a:t>Rules that still hold on test games (%)</a:t>
+            </a:r>
+          </a:p>
+        </c:rich>
+      </c:tx>
+      <c:layout/>
+      <c:overlay val="0"/>
+    </c:title>
+    <c:autoTitleDeleted val="0"/>
+    <c:plotArea>
+      <c:barChart>
+        <c:barDir val="col"/>
+        <c:grouping val="clustered"/>
+        <c:ser>
+          <c:idx val="0"/>
+          <c:order val="0"/>
+          <c:tx>
+            <c:strRef>
+              <c:f>Sheet1!$B$1</c:f>
+              <c:strCache>
+                <c:ptCount val="1"/>
+                <c:pt idx="0">
+                  <c:v>hold on test</c:v>
+                </c:pt>
+              </c:strCache>
+            </c:strRef>
+          </c:tx>
+          <c:spPr>
+            <a:solidFill>
+              <a:srgbClr val="157A80"/>
+            </a:solidFill>
+          </c:spPr>
+          <c:invertIfNegative val="0"/>
+          <c:cat>
+            <c:strRef>
+              <c:f>Sheet1!$A$2:$A$7</c:f>
+              <c:strCache>
+                <c:ptCount val="6"/>
+                <c:pt idx="0">
+                  <c:v>chosen</c:v>
+                </c:pt>
+                <c:pt idx="1">
+                  <c:v>Apriori</c:v>
+                </c:pt>
+                <c:pt idx="2">
+                  <c:v>support 15</c:v>
+                </c:pt>
+                <c:pt idx="3">
+                  <c:v>support 40</c:v>
+                </c:pt>
+                <c:pt idx="4">
+                  <c:v>pairs only</c:v>
+                </c:pt>
+                <c:pt idx="5">
+                  <c:v>+ after-play</c:v>
+                </c:pt>
+              </c:strCache>
+            </c:strRef>
+          </c:cat>
+          <c:val>
+            <c:numRef>
+              <c:f>Sheet1!$B$2:$B$7</c:f>
+              <c:numCache>
+                <c:formatCode>General</c:formatCode>
+                <c:ptCount val="6"/>
+                <c:pt idx="0">
+                  <c:v>68.18181818181817</c:v>
+                </c:pt>
+                <c:pt idx="1">
+                  <c:v>68.18181818181817</c:v>
+                </c:pt>
+                <c:pt idx="2">
+                  <c:v>66.07142857142857</c:v>
+                </c:pt>
+                <c:pt idx="3">
+                  <c:v>69.49152542372882</c:v>
+                </c:pt>
+                <c:pt idx="4">
+                  <c:v>83.33333333333334</c:v>
+                </c:pt>
+                <c:pt idx="5">
+                  <c:v>69.31818181818183</c:v>
+                </c:pt>
+              </c:numCache>
+            </c:numRef>
+          </c:val>
+        </c:ser>
+        <c:dLbls>
+          <c:numFmt formatCode="0&quot;%&quot;" sourceLinked="0"/>
+          <c:txPr>
+            <a:bodyPr/>
+            <a:lstStyle/>
+            <a:p>
+              <a:pPr>
+                <a:defRPr sz="900"/>
+              </a:pPr>
+            </a:p>
+          </c:txPr>
+          <c:dLblPos val="outEnd"/>
+          <c:showLegendKey val="0"/>
+          <c:showVal val="1"/>
+          <c:showCatName val="0"/>
+          <c:showSerName val="0"/>
+          <c:showPercent val="0"/>
+          <c:showBubbleSize val="0"/>
+          <c:showLeaderLines val="1"/>
+        </c:dLbls>
+        <c:gapWidth val="55"/>
+        <c:axId val="-2068027336"/>
+        <c:axId val="-2113994440"/>
+      </c:barChart>
+      <c:catAx>
+        <c:axId val="-2068027336"/>
+        <c:scaling>
+          <c:orientation val="minMax"/>
+        </c:scaling>
+        <c:delete val="0"/>
+        <c:axPos val="b"/>
+        <c:majorTickMark val="out"/>
+        <c:minorTickMark val="none"/>
+        <c:tickLblPos val="nextTo"/>
+        <c:spPr>
+          <a:ln>
+            <a:solidFill>
+              <a:srgbClr val="C9D6E2"/>
+            </a:solidFill>
+          </a:ln>
+        </c:spPr>
+        <c:txPr>
+          <a:bodyPr/>
+          <a:lstStyle/>
+          <a:p>
+            <a:pPr>
+              <a:defRPr sz="900"/>
+            </a:pPr>
+          </a:p>
+        </c:txPr>
+        <c:crossAx val="-2113994440"/>
+        <c:crosses val="autoZero"/>
+        <c:auto val="1"/>
+        <c:lblAlgn val="ctr"/>
+        <c:lblOffset val="100"/>
+        <c:noMultiLvlLbl val="0"/>
+      </c:catAx>
+      <c:valAx>
+        <c:axId val="-2113994440"/>
+        <c:scaling>
+          <c:max val="100.0"/>
           <c:min val="0.0"/>
         </c:scaling>
         <c:delete/>
@@ -1177,7 +2638,7 @@
           <a:lstStyle xmlns:a="http://schemas.openxmlformats.org/drawingml/2006/main"/>
           <a:p xmlns:a="http://schemas.openxmlformats.org/drawingml/2006/main">
             <a:r>
-              <a:t>Suggested speaker: Tejaswini. 1:05.</a:t>
+              <a:t>Suggested speaker: Tejaswini. 0:55.</a:t>
             </a:r>
           </a:p>
           <a:p xmlns:a="http://schemas.openxmlformats.org/drawingml/2006/main">
@@ -1257,7 +2718,7 @@
           </a:p>
           <a:p xmlns:a="http://schemas.openxmlformats.org/drawingml/2006/main">
             <a:r>
-              <a:t>Transactions, thresholds and the train-then-test protocol. Support, confidence and lift are defined on slide 13's table and in notebooks/review2/association_rules.ipynb.</a:t>
+              <a:t>Transactions, thresholds and the train-then-test protocol. Support, confidence and lift are defined on slide 16's table and in notebooks/review2/association_rules.ipynb.</a:t>
             </a:r>
           </a:p>
         </p:txBody>
@@ -1327,7 +2788,7 @@
           <a:lstStyle xmlns:a="http://schemas.openxmlformats.org/drawingml/2006/main"/>
           <a:p xmlns:a="http://schemas.openxmlformats.org/drawingml/2006/main">
             <a:r>
-              <a:t>Suggested speaker: Pradeep. 1:05.</a:t>
+              <a:t>Suggested speaker: Pradeep. 0:55.</a:t>
             </a:r>
           </a:p>
           <a:p xmlns:a="http://schemas.openxmlformats.org/drawingml/2006/main">
@@ -1662,6 +3123,156 @@
 </p:notes>
 </file>
 
+<file path=ppt/notesSlides/notesSlide18.xml><?xml version="1.0" encoding="utf-8"?>
+<p:notes xmlns:a="http://schemas.openxmlformats.org/drawingml/2006/main" xmlns:p="http://schemas.openxmlformats.org/presentationml/2006/main" xmlns:r="http://schemas.openxmlformats.org/officeDocument/2006/relationships">
+  <p:cSld>
+    <p:spTree>
+      <p:nvGrpSpPr>
+        <p:cNvPr id="1" name=""/>
+        <p:cNvGrpSpPr/>
+        <p:nvPr/>
+      </p:nvGrpSpPr>
+      <p:grpSpPr>
+        <a:xfrm>
+          <a:off x="0" y="0"/>
+          <a:ext cx="0" cy="0"/>
+          <a:chOff x="0" y="0"/>
+          <a:chExt cx="0" cy="0"/>
+        </a:xfrm>
+      </p:grpSpPr>
+      <p:sp>
+        <p:nvSpPr>
+          <p:cNvPr id="2" name="Slide Image Placeholder 1"/>
+          <p:cNvSpPr>
+            <a:spLocks noGrp="1"/>
+          </p:cNvSpPr>
+          <p:nvPr>
+            <p:ph type="sldImg" idx="2"/>
+          </p:nvPr>
+        </p:nvSpPr>
+        <p:spPr/>
+      </p:sp>
+      <p:sp>
+        <p:nvSpPr>
+          <p:cNvPr id="3" name="Notes Placeholder 2"/>
+          <p:cNvSpPr>
+            <a:spLocks noGrp="1"/>
+          </p:cNvSpPr>
+          <p:nvPr>
+            <p:ph type="body" idx="3" sz="quarter"/>
+          </p:nvPr>
+        </p:nvSpPr>
+        <p:spPr/>
+        <p:txBody>
+          <a:bodyPr/>
+          <a:lstStyle/>
+          <a:p>
+            <a:r>
+              <a:t>Suggested speaker: Pradeep. 0:20.</a:t>
+            </a:r>
+          </a:p>
+          <a:p>
+            <a:r>
+              <a:t>Same numbers as the table, drawn as bars. Compare each bar with the guessing baseline, not with 1.0.</a:t>
+            </a:r>
+          </a:p>
+        </p:txBody>
+      </p:sp>
+      <p:sp>
+        <p:nvSpPr>
+          <p:cNvPr id="4" name="Slide Number Placeholder 3"/>
+          <p:cNvSpPr>
+            <a:spLocks noGrp="1"/>
+          </p:cNvSpPr>
+          <p:nvPr>
+            <p:ph type="sldNum" idx="5" sz="quarter"/>
+          </p:nvPr>
+        </p:nvSpPr>
+        <p:spPr/>
+      </p:sp>
+    </p:spTree>
+  </p:cSld>
+  <p:clrMapOvr>
+    <a:masterClrMapping/>
+  </p:clrMapOvr>
+</p:notes>
+</file>
+
+<file path=ppt/notesSlides/notesSlide19.xml><?xml version="1.0" encoding="utf-8"?>
+<p:notes xmlns:a="http://schemas.openxmlformats.org/drawingml/2006/main" xmlns:p="http://schemas.openxmlformats.org/presentationml/2006/main" xmlns:r="http://schemas.openxmlformats.org/officeDocument/2006/relationships">
+  <p:cSld>
+    <p:spTree>
+      <p:nvGrpSpPr>
+        <p:cNvPr id="1" name=""/>
+        <p:cNvGrpSpPr/>
+        <p:nvPr/>
+      </p:nvGrpSpPr>
+      <p:grpSpPr>
+        <a:xfrm>
+          <a:off x="0" y="0"/>
+          <a:ext cx="0" cy="0"/>
+          <a:chOff x="0" y="0"/>
+          <a:chExt cx="0" cy="0"/>
+        </a:xfrm>
+      </p:grpSpPr>
+      <p:sp>
+        <p:nvSpPr>
+          <p:cNvPr id="2" name="Slide Image Placeholder 1"/>
+          <p:cNvSpPr>
+            <a:spLocks noGrp="1"/>
+          </p:cNvSpPr>
+          <p:nvPr>
+            <p:ph type="sldImg" idx="2"/>
+          </p:nvPr>
+        </p:nvSpPr>
+        <p:spPr/>
+      </p:sp>
+      <p:sp>
+        <p:nvSpPr>
+          <p:cNvPr id="3" name="Notes Placeholder 2"/>
+          <p:cNvSpPr>
+            <a:spLocks noGrp="1"/>
+          </p:cNvSpPr>
+          <p:nvPr>
+            <p:ph type="body" idx="3" sz="quarter"/>
+          </p:nvPr>
+        </p:nvSpPr>
+        <p:spPr/>
+        <p:txBody>
+          <a:bodyPr/>
+          <a:lstStyle/>
+          <a:p>
+            <a:r>
+              <a:t>Suggested speaker: Tejaswini. 0:20.</a:t>
+            </a:r>
+          </a:p>
+          <a:p>
+            <a:r>
+              <a:t>Left: same test reviews, four approaches. Right: the topic model's dominant theme among negative reviews, early against later; treat the themes as exploratory.</a:t>
+            </a:r>
+          </a:p>
+        </p:txBody>
+      </p:sp>
+      <p:sp>
+        <p:nvSpPr>
+          <p:cNvPr id="4" name="Slide Number Placeholder 3"/>
+          <p:cNvSpPr>
+            <a:spLocks noGrp="1"/>
+          </p:cNvSpPr>
+          <p:nvPr>
+            <p:ph type="sldNum" idx="5" sz="quarter"/>
+          </p:nvPr>
+        </p:nvSpPr>
+        <p:spPr/>
+      </p:sp>
+    </p:spTree>
+  </p:cSld>
+  <p:clrMapOvr>
+    <a:masterClrMapping/>
+  </p:clrMapOvr>
+</p:notes>
+</file>
+
 <file path=ppt/notesSlides/notesSlide2.xml><?xml version="1.0" encoding="utf-8"?>
 <p:notes xmlns:p="http://schemas.openxmlformats.org/presentationml/2006/main">
   <p:cSld>
@@ -1733,6 +3344,81 @@
   </p:cSld>
   <p:clrMapOvr>
     <a:masterClrMapping xmlns:a="http://schemas.openxmlformats.org/drawingml/2006/main"/>
+  </p:clrMapOvr>
+</p:notes>
+</file>
+
+<file path=ppt/notesSlides/notesSlide20.xml><?xml version="1.0" encoding="utf-8"?>
+<p:notes xmlns:a="http://schemas.openxmlformats.org/drawingml/2006/main" xmlns:p="http://schemas.openxmlformats.org/presentationml/2006/main" xmlns:r="http://schemas.openxmlformats.org/officeDocument/2006/relationships">
+  <p:cSld>
+    <p:spTree>
+      <p:nvGrpSpPr>
+        <p:cNvPr id="1" name=""/>
+        <p:cNvGrpSpPr/>
+        <p:nvPr/>
+      </p:nvGrpSpPr>
+      <p:grpSpPr>
+        <a:xfrm>
+          <a:off x="0" y="0"/>
+          <a:ext cx="0" cy="0"/>
+          <a:chOff x="0" y="0"/>
+          <a:chExt cx="0" cy="0"/>
+        </a:xfrm>
+      </p:grpSpPr>
+      <p:sp>
+        <p:nvSpPr>
+          <p:cNvPr id="2" name="Slide Image Placeholder 1"/>
+          <p:cNvSpPr>
+            <a:spLocks noGrp="1"/>
+          </p:cNvSpPr>
+          <p:nvPr>
+            <p:ph type="sldImg" idx="2"/>
+          </p:nvPr>
+        </p:nvSpPr>
+        <p:spPr/>
+      </p:sp>
+      <p:sp>
+        <p:nvSpPr>
+          <p:cNvPr id="3" name="Notes Placeholder 2"/>
+          <p:cNvSpPr>
+            <a:spLocks noGrp="1"/>
+          </p:cNvSpPr>
+          <p:nvPr>
+            <p:ph type="body" idx="3" sz="quarter"/>
+          </p:nvPr>
+        </p:nvSpPr>
+        <p:spPr/>
+        <p:txBody>
+          <a:bodyPr/>
+          <a:lstStyle/>
+          <a:p>
+            <a:r>
+              <a:t>Suggested speaker: Pradeep. 0:20.</a:t>
+            </a:r>
+          </a:p>
+          <a:p>
+            <a:r>
+              <a:t>Training bars come from the 1,191 training games, test bars from the 299 test games. Lower test bars are expected after picking the best rules on training data.</a:t>
+            </a:r>
+          </a:p>
+        </p:txBody>
+      </p:sp>
+      <p:sp>
+        <p:nvSpPr>
+          <p:cNvPr id="4" name="Slide Number Placeholder 3"/>
+          <p:cNvSpPr>
+            <a:spLocks noGrp="1"/>
+          </p:cNvSpPr>
+          <p:nvPr>
+            <p:ph type="sldNum" idx="5" sz="quarter"/>
+          </p:nvPr>
+        </p:nvSpPr>
+        <p:spPr/>
+      </p:sp>
+    </p:spTree>
+  </p:cSld>
+  <p:clrMapOvr>
+    <a:masterClrMapping/>
   </p:clrMapOvr>
 </p:notes>
 </file>
@@ -2152,7 +3838,7 @@
           <a:lstStyle xmlns:a="http://schemas.openxmlformats.org/drawingml/2006/main"/>
           <a:p xmlns:a="http://schemas.openxmlformats.org/drawingml/2006/main">
             <a:r>
-              <a:t>Suggested speaker: Pradeep. 1:05.</a:t>
+              <a:t>Suggested speaker: Pradeep. 0:50.</a:t>
             </a:r>
           </a:p>
           <a:p xmlns:a="http://schemas.openxmlformats.org/drawingml/2006/main">
@@ -5135,7 +6821,7 @@
                 <a:ea typeface="Arial"/>
                 <a:cs typeface="Arial"/>
               </a:rPr>
-              <a:t>10</a:t>
+              <a:t>11</a:t>
             </a:r>
           </a:p>
         </p:txBody>
@@ -6635,7 +8321,7 @@
                 <a:ea typeface="Arial"/>
                 <a:cs typeface="Arial"/>
               </a:rPr>
-              <a:t>11</a:t>
+              <a:t>13</a:t>
             </a:r>
           </a:p>
         </p:txBody>
@@ -7994,7 +9680,7 @@
                 <a:ea typeface="Arial"/>
                 <a:cs typeface="Arial"/>
               </a:rPr>
-              <a:t>12</a:t>
+              <a:t>14</a:t>
             </a:r>
           </a:p>
         </p:txBody>
@@ -9430,7 +11116,7 @@
                 <a:ea typeface="Arial"/>
                 <a:cs typeface="Arial"/>
               </a:rPr>
-              <a:t>13</a:t>
+              <a:t>16</a:t>
             </a:r>
           </a:p>
         </p:txBody>
@@ -11102,7 +12788,7 @@
                 <a:ea typeface="Arial"/>
                 <a:cs typeface="Arial"/>
               </a:rPr>
-              <a:t>14</a:t>
+              <a:t>17</a:t>
             </a:r>
           </a:p>
         </p:txBody>
@@ -11993,7 +13679,7 @@
                 <a:ea typeface="Arial"/>
                 <a:cs typeface="Arial"/>
               </a:rPr>
-              <a:t>15</a:t>
+              <a:t>18</a:t>
             </a:r>
           </a:p>
         </p:txBody>
@@ -12481,7 +14167,7 @@
                 <a:ea typeface="Arial"/>
                 <a:cs typeface="Arial"/>
               </a:rPr>
-              <a:t>16</a:t>
+              <a:t>19</a:t>
             </a:r>
           </a:p>
         </p:txBody>
@@ -13521,7 +15207,7 @@
                 <a:ea typeface="Arial"/>
                 <a:cs typeface="Arial"/>
               </a:rPr>
-              <a:t>17</a:t>
+              <a:t>20</a:t>
             </a:r>
           </a:p>
         </p:txBody>
@@ -13845,6 +15531,940 @@
       </p:ext>
     </p:extLst>
   </p:cSld>
+</p:sld>
+</file>
+
+<file path=ppt/slides/slide18.xml><?xml version="1.0" encoding="utf-8"?>
+<p:sld xmlns:a="http://schemas.openxmlformats.org/drawingml/2006/main" xmlns:p="http://schemas.openxmlformats.org/presentationml/2006/main" xmlns:r="http://schemas.openxmlformats.org/officeDocument/2006/relationships">
+  <p:cSld>
+    <p:spTree>
+      <p:nvGrpSpPr>
+        <p:cNvPr id="1" name=""/>
+        <p:cNvGrpSpPr/>
+        <p:nvPr/>
+      </p:nvGrpSpPr>
+      <p:grpSpPr/>
+      <p:sp>
+        <p:nvSpPr>
+          <p:cNvPr id="7" name="">
+            <a:extLst>
+              <a:ext uri="{FF2B5EF4-FFF2-40B4-BE49-F238E27FC236}">
+                <a16:creationId xmlns:a16="http://schemas.microsoft.com/office/drawing/2014/main" id="{FFD34040-A608-4A4D-9436-08E9A32AB30D}"/>
+              </a:ext>
+            </a:extLst>
+          </p:cNvPr>
+          <p:cNvSpPr>
+            <a:spLocks noGrp="1"/>
+          </p:cNvSpPr>
+          <p:nvPr/>
+        </p:nvSpPr>
+        <p:spPr>
+          <a:xfrm>
+            <a:off x="609600" y="342900"/>
+            <a:ext cx="10477500" cy="285750"/>
+          </a:xfrm>
+          <a:prstGeom prst="rect">
+            <a:avLst/>
+          </a:prstGeom>
+          <a:noFill/>
+          <a:ln w="0">
+            <a:noFill/>
+            <a:prstDash val="solid"/>
+          </a:ln>
+        </p:spPr>
+        <p:txBody>
+          <a:bodyPr/>
+          <a:lstStyle>
+            <a:defPPr>
+              <a:defRPr sz="1350" b="1">
+                <a:solidFill>
+                  <a:srgbClr val="157A80"/>
+                </a:solidFill>
+                <a:latin typeface="Arial"/>
+                <a:ea typeface="Arial"/>
+                <a:cs typeface="Arial"/>
+              </a:defRPr>
+            </a:defPPr>
+          </a:lstStyle>
+          <a:p>
+            <a:pPr>
+              <a:defRPr sz="1350" b="1">
+                <a:solidFill>
+                  <a:srgbClr val="157A80"/>
+                </a:solidFill>
+                <a:latin typeface="Arial"/>
+                <a:ea typeface="Arial"/>
+                <a:cs typeface="Arial"/>
+              </a:defRPr>
+            </a:pPr>
+            <a:r>
+              <a:rPr sz="1350" b="1">
+                <a:solidFill>
+                  <a:srgbClr val="157A80"/>
+                </a:solidFill>
+                <a:latin typeface="Arial"/>
+                <a:ea typeface="Arial"/>
+                <a:cs typeface="Arial"/>
+              </a:rPr>
+              <a:t>UNIT 2</a:t>
+            </a:r>
+          </a:p>
+        </p:txBody>
+      </p:sp>
+      <p:sp>
+        <p:nvSpPr>
+          <p:cNvPr id="2" name="">
+            <a:extLst>
+              <a:ext uri="{FF2B5EF4-FFF2-40B4-BE49-F238E27FC236}">
+                <a16:creationId xmlns:a16="http://schemas.microsoft.com/office/drawing/2014/main" id="{897D50C3-2951-437D-9286-819C0AD2206D}"/>
+              </a:ext>
+            </a:extLst>
+          </p:cNvPr>
+          <p:cNvSpPr>
+            <a:spLocks noGrp="1"/>
+          </p:cNvSpPr>
+          <p:nvPr/>
+        </p:nvSpPr>
+        <p:spPr>
+          <a:xfrm>
+            <a:off x="609600" y="838200"/>
+            <a:ext cx="10972800" cy="857250"/>
+          </a:xfrm>
+          <a:prstGeom prst="rect">
+            <a:avLst/>
+          </a:prstGeom>
+          <a:noFill/>
+          <a:ln w="0">
+            <a:noFill/>
+            <a:prstDash val="solid"/>
+          </a:ln>
+        </p:spPr>
+        <p:txBody>
+          <a:bodyPr/>
+          <a:lstStyle>
+            <a:defPPr>
+              <a:defRPr sz="3150" b="1">
+                <a:solidFill>
+                  <a:srgbClr val="142D4E"/>
+                </a:solidFill>
+                <a:latin typeface="Arial"/>
+                <a:ea typeface="Arial"/>
+                <a:cs typeface="Arial"/>
+              </a:defRPr>
+            </a:defPPr>
+          </a:lstStyle>
+          <a:p>
+            <a:pPr>
+              <a:defRPr sz="3150" b="1">
+                <a:solidFill>
+                  <a:srgbClr val="142D4E"/>
+                </a:solidFill>
+                <a:latin typeface="Arial"/>
+                <a:ea typeface="Arial"/>
+                <a:cs typeface="Arial"/>
+              </a:defRPr>
+            </a:pPr>
+            <a:r>
+              <a:rPr sz="3150" b="1">
+                <a:solidFill>
+                  <a:srgbClr val="142D4E"/>
+                </a:solidFill>
+                <a:latin typeface="Arial"/>
+                <a:ea typeface="Arial"/>
+                <a:cs typeface="Arial"/>
+              </a:rPr>
+              <a:t>Model comparison at a glance</a:t>
+            </a:r>
+          </a:p>
+        </p:txBody>
+      </p:sp>
+      <p:sp>
+        <p:nvSpPr>
+          <p:cNvPr id="3" name="">
+            <a:extLst>
+              <a:ext uri="{FF2B5EF4-FFF2-40B4-BE49-F238E27FC236}">
+                <a16:creationId xmlns:a16="http://schemas.microsoft.com/office/drawing/2014/main" id="{0D4E2AA2-04B0-4D08-98E4-3A8D9DD5E6B7}"/>
+              </a:ext>
+            </a:extLst>
+          </p:cNvPr>
+          <p:cNvSpPr>
+            <a:spLocks noGrp="1"/>
+          </p:cNvSpPr>
+          <p:nvPr/>
+        </p:nvSpPr>
+        <p:spPr>
+          <a:xfrm>
+            <a:off x="10953750" y="6343650"/>
+            <a:ext cx="619125" cy="238125"/>
+          </a:xfrm>
+          <a:prstGeom prst="rect">
+            <a:avLst/>
+          </a:prstGeom>
+          <a:noFill/>
+          <a:ln w="0">
+            <a:noFill/>
+            <a:prstDash val="solid"/>
+          </a:ln>
+        </p:spPr>
+        <p:txBody>
+          <a:bodyPr/>
+          <a:lstStyle>
+            <a:defPPr>
+              <a:defRPr sz="1200" b="0">
+                <a:solidFill>
+                  <a:srgbClr val="66758A"/>
+                </a:solidFill>
+                <a:latin typeface="Arial"/>
+                <a:ea typeface="Arial"/>
+                <a:cs typeface="Arial"/>
+              </a:defRPr>
+            </a:defPPr>
+          </a:lstStyle>
+          <a:p>
+            <a:pPr>
+              <a:defRPr sz="1200" b="0">
+                <a:solidFill>
+                  <a:srgbClr val="66758A"/>
+                </a:solidFill>
+                <a:latin typeface="Arial"/>
+                <a:ea typeface="Arial"/>
+                <a:cs typeface="Arial"/>
+              </a:defRPr>
+            </a:pPr>
+            <a:r>
+              <a:rPr sz="1200" b="0">
+                <a:solidFill>
+                  <a:srgbClr val="66758A"/>
+                </a:solidFill>
+                <a:latin typeface="Arial"/>
+                <a:ea typeface="Arial"/>
+                <a:cs typeface="Arial"/>
+              </a:rPr>
+              <a:t>09</a:t>
+            </a:r>
+          </a:p>
+        </p:txBody>
+      </p:sp>
+      <p:graphicFrame>
+        <p:nvGraphicFramePr>
+          <p:cNvPr id="8" name="Chart 7"/>
+          <p:cNvGraphicFramePr>
+            <a:graphicFrameLocks noGrp="1"/>
+          </p:cNvGraphicFramePr>
+          <p:nvPr/>
+        </p:nvGraphicFramePr>
+        <p:xfrm>
+          <a:off x="612648" y="1691640"/>
+          <a:ext cx="5852160" cy="3291840"/>
+        </p:xfrm>
+        <a:graphic>
+          <a:graphicData uri="http://schemas.openxmlformats.org/drawingml/2006/chart">
+            <c:chart xmlns:c="http://schemas.openxmlformats.org/drawingml/2006/chart" r:id="rId2"/>
+          </a:graphicData>
+        </a:graphic>
+      </p:graphicFrame>
+      <p:graphicFrame>
+        <p:nvGraphicFramePr>
+          <p:cNvPr id="9" name="Chart 8"/>
+          <p:cNvGraphicFramePr>
+            <a:graphicFrameLocks noGrp="1"/>
+          </p:cNvGraphicFramePr>
+          <p:nvPr/>
+        </p:nvGraphicFramePr>
+        <p:xfrm>
+          <a:off x="6583680" y="1691640"/>
+          <a:ext cx="5029200" cy="3291840"/>
+        </p:xfrm>
+        <a:graphic>
+          <a:graphicData uri="http://schemas.openxmlformats.org/drawingml/2006/chart">
+            <c:chart xmlns:c="http://schemas.openxmlformats.org/drawingml/2006/chart" r:id="rId3"/>
+          </a:graphicData>
+        </a:graphic>
+      </p:graphicFrame>
+      <p:sp>
+        <p:nvSpPr>
+          <p:cNvPr id="10" name="Rectangle 9"/>
+          <p:cNvSpPr/>
+          <p:nvPr/>
+        </p:nvSpPr>
+        <p:spPr>
+          <a:xfrm>
+            <a:off x="612648" y="5029200"/>
+            <a:ext cx="10972800" cy="777240"/>
+          </a:xfrm>
+          <a:prstGeom prst="rect">
+            <a:avLst/>
+          </a:prstGeom>
+          <a:solidFill>
+            <a:srgbClr val="FFFFFF"/>
+          </a:solidFill>
+          <a:ln>
+            <a:noFill/>
+          </a:ln>
+          <a:effectLst/>
+        </p:spPr>
+        <p:style>
+          <a:lnRef idx="1">
+            <a:schemeClr val="accent1"/>
+          </a:lnRef>
+          <a:fillRef idx="3">
+            <a:schemeClr val="accent1"/>
+          </a:fillRef>
+          <a:effectRef idx="2">
+            <a:schemeClr val="accent1"/>
+          </a:effectRef>
+          <a:fontRef idx="minor">
+            <a:schemeClr val="lt1"/>
+          </a:fontRef>
+        </p:style>
+        <p:txBody>
+          <a:bodyPr rtlCol="0" anchor="t" wrap="square" lIns="45720" rIns="45720" tIns="36576" bIns="36576"/>
+          <a:lstStyle/>
+          <a:p>
+            <a:pPr algn="l"/>
+            <a:r>
+              <a:rPr sz="1200" b="1">
+                <a:solidFill>
+                  <a:srgbClr val="142D4E"/>
+                </a:solidFill>
+                <a:latin typeface="Arial"/>
+              </a:rPr>
+              <a:t>How to read it: </a:t>
+            </a:r>
+            <a:r>
+              <a:rPr sz="1200" b="0">
+                <a:solidFill>
+                  <a:srgbClr val="233247"/>
+                </a:solidFill>
+                <a:latin typeface="Arial"/>
+              </a:rPr>
+              <a:t>guessing scores PR-AUC 0.106, ROC-AUC 0.500 and macro-F1 0.220. The three tree models tie at review level; at game level tuned XGBoost and Logistic Regression lead, and the intervals overlap (299 test games). Settings were tuned by grid search; the test set was scored once.</a:t>
+            </a:r>
+          </a:p>
+        </p:txBody>
+      </p:sp>
+      <p:sp>
+        <p:nvSpPr>
+          <p:cNvPr id="11" name="Rectangle 10"/>
+          <p:cNvSpPr/>
+          <p:nvPr/>
+        </p:nvSpPr>
+        <p:spPr>
+          <a:xfrm>
+            <a:off x="612648" y="5916168"/>
+            <a:ext cx="10972800" cy="420624"/>
+          </a:xfrm>
+          <a:prstGeom prst="rect">
+            <a:avLst/>
+          </a:prstGeom>
+          <a:solidFill>
+            <a:srgbClr val="EEF2F7"/>
+          </a:solidFill>
+          <a:ln>
+            <a:noFill/>
+          </a:ln>
+          <a:effectLst/>
+        </p:spPr>
+        <p:style>
+          <a:lnRef idx="1">
+            <a:schemeClr val="accent1"/>
+          </a:lnRef>
+          <a:fillRef idx="3">
+            <a:schemeClr val="accent1"/>
+          </a:fillRef>
+          <a:effectRef idx="2">
+            <a:schemeClr val="accent1"/>
+          </a:effectRef>
+          <a:fontRef idx="minor">
+            <a:schemeClr val="lt1"/>
+          </a:fontRef>
+        </p:style>
+        <p:txBody>
+          <a:bodyPr rtlCol="0" anchor="ctr"/>
+          <a:lstStyle/>
+          <a:p>
+            <a:pPr algn="ctr"/>
+          </a:p>
+        </p:txBody>
+      </p:sp>
+      <p:sp>
+        <p:nvSpPr>
+          <p:cNvPr id="12" name="Rectangle 11"/>
+          <p:cNvSpPr/>
+          <p:nvPr/>
+        </p:nvSpPr>
+        <p:spPr>
+          <a:xfrm>
+            <a:off x="612648" y="5916168"/>
+            <a:ext cx="64008" cy="420624"/>
+          </a:xfrm>
+          <a:prstGeom prst="rect">
+            <a:avLst/>
+          </a:prstGeom>
+          <a:solidFill>
+            <a:srgbClr val="C44E52"/>
+          </a:solidFill>
+          <a:ln>
+            <a:noFill/>
+          </a:ln>
+          <a:effectLst/>
+        </p:spPr>
+        <p:style>
+          <a:lnRef idx="1">
+            <a:schemeClr val="accent1"/>
+          </a:lnRef>
+          <a:fillRef idx="3">
+            <a:schemeClr val="accent1"/>
+          </a:fillRef>
+          <a:effectRef idx="2">
+            <a:schemeClr val="accent1"/>
+          </a:effectRef>
+          <a:fontRef idx="minor">
+            <a:schemeClr val="lt1"/>
+          </a:fontRef>
+        </p:style>
+        <p:txBody>
+          <a:bodyPr rtlCol="0" anchor="ctr"/>
+          <a:lstStyle/>
+          <a:p>
+            <a:pPr algn="ctr"/>
+          </a:p>
+        </p:txBody>
+      </p:sp>
+      <p:sp>
+        <p:nvSpPr>
+          <p:cNvPr id="13" name="Rectangle 12"/>
+          <p:cNvSpPr/>
+          <p:nvPr/>
+        </p:nvSpPr>
+        <p:spPr>
+          <a:xfrm>
+            <a:off x="676656" y="5916168"/>
+            <a:ext cx="10908792" cy="420624"/>
+          </a:xfrm>
+          <a:prstGeom prst="rect">
+            <a:avLst/>
+          </a:prstGeom>
+          <a:solidFill>
+            <a:srgbClr val="EEF2F7"/>
+          </a:solidFill>
+          <a:ln>
+            <a:noFill/>
+          </a:ln>
+          <a:effectLst/>
+        </p:spPr>
+        <p:style>
+          <a:lnRef idx="1">
+            <a:schemeClr val="accent1"/>
+          </a:lnRef>
+          <a:fillRef idx="3">
+            <a:schemeClr val="accent1"/>
+          </a:fillRef>
+          <a:effectRef idx="2">
+            <a:schemeClr val="accent1"/>
+          </a:effectRef>
+          <a:fontRef idx="minor">
+            <a:schemeClr val="lt1"/>
+          </a:fontRef>
+        </p:style>
+        <p:txBody>
+          <a:bodyPr rtlCol="0" anchor="ctr" wrap="square" tIns="36576" bIns="36576"/>
+          <a:lstStyle/>
+          <a:p>
+            <a:pPr algn="l"/>
+            <a:r>
+              <a:rPr sz="1200" b="1">
+                <a:solidFill>
+                  <a:srgbClr val="C44E52"/>
+                </a:solidFill>
+                <a:latin typeface="Arial"/>
+              </a:rPr>
+              <a:t>Takeaway   </a:t>
+            </a:r>
+            <a:r>
+              <a:rPr sz="1200" b="0">
+                <a:solidFill>
+                  <a:srgbClr val="233247"/>
+                </a:solidFill>
+                <a:latin typeface="Arial"/>
+              </a:rPr>
+              <a:t>Every model beats guessing, but store metadata alone reaches only ROC-AUC 0.73 and macro-F1 0.44; the next slides add the review text.</a:t>
+            </a:r>
+          </a:p>
+        </p:txBody>
+      </p:sp>
+    </p:spTree>
+  </p:cSld>
+  <p:clrMapOvr>
+    <a:masterClrMapping/>
+  </p:clrMapOvr>
+</p:sld>
+</file>
+
+<file path=ppt/slides/slide19.xml><?xml version="1.0" encoding="utf-8"?>
+<p:sld xmlns:a="http://schemas.openxmlformats.org/drawingml/2006/main" xmlns:p="http://schemas.openxmlformats.org/presentationml/2006/main" xmlns:r="http://schemas.openxmlformats.org/officeDocument/2006/relationships">
+  <p:cSld>
+    <p:spTree>
+      <p:nvGrpSpPr>
+        <p:cNvPr id="1" name=""/>
+        <p:cNvGrpSpPr/>
+        <p:nvPr/>
+      </p:nvGrpSpPr>
+      <p:grpSpPr/>
+      <p:sp>
+        <p:nvSpPr>
+          <p:cNvPr id="7" name="">
+            <a:extLst>
+              <a:ext uri="{FF2B5EF4-FFF2-40B4-BE49-F238E27FC236}">
+                <a16:creationId xmlns:a16="http://schemas.microsoft.com/office/drawing/2014/main" id="{CBA0D3AE-4AF7-4CC4-8F37-1474DB9B9BA5}"/>
+              </a:ext>
+            </a:extLst>
+          </p:cNvPr>
+          <p:cNvSpPr>
+            <a:spLocks noGrp="1"/>
+          </p:cNvSpPr>
+          <p:nvPr/>
+        </p:nvSpPr>
+        <p:spPr>
+          <a:xfrm>
+            <a:off x="609600" y="342900"/>
+            <a:ext cx="10477500" cy="285750"/>
+          </a:xfrm>
+          <a:prstGeom prst="rect">
+            <a:avLst/>
+          </a:prstGeom>
+          <a:noFill/>
+          <a:ln w="0">
+            <a:noFill/>
+            <a:prstDash val="solid"/>
+          </a:ln>
+        </p:spPr>
+        <p:txBody>
+          <a:bodyPr/>
+          <a:lstStyle>
+            <a:defPPr>
+              <a:defRPr sz="1350" b="1">
+                <a:solidFill>
+                  <a:srgbClr val="157A80"/>
+                </a:solidFill>
+                <a:latin typeface="Arial"/>
+                <a:ea typeface="Arial"/>
+                <a:cs typeface="Arial"/>
+              </a:defRPr>
+            </a:defPPr>
+          </a:lstStyle>
+          <a:p>
+            <a:pPr>
+              <a:defRPr sz="1350" b="1">
+                <a:solidFill>
+                  <a:srgbClr val="157A80"/>
+                </a:solidFill>
+                <a:latin typeface="Arial"/>
+                <a:ea typeface="Arial"/>
+                <a:cs typeface="Arial"/>
+              </a:defRPr>
+            </a:pPr>
+            <a:r>
+              <a:rPr sz="1350" b="1">
+                <a:solidFill>
+                  <a:srgbClr val="157A80"/>
+                </a:solidFill>
+                <a:latin typeface="Arial"/>
+                <a:ea typeface="Arial"/>
+                <a:cs typeface="Arial"/>
+              </a:rPr>
+              <a:t>UNIT 3</a:t>
+            </a:r>
+          </a:p>
+        </p:txBody>
+      </p:sp>
+      <p:sp>
+        <p:nvSpPr>
+          <p:cNvPr id="2" name="">
+            <a:extLst>
+              <a:ext uri="{FF2B5EF4-FFF2-40B4-BE49-F238E27FC236}">
+                <a16:creationId xmlns:a16="http://schemas.microsoft.com/office/drawing/2014/main" id="{78BB2EEA-EA2C-4AF7-AF01-C4956469B876}"/>
+              </a:ext>
+            </a:extLst>
+          </p:cNvPr>
+          <p:cNvSpPr>
+            <a:spLocks noGrp="1"/>
+          </p:cNvSpPr>
+          <p:nvPr/>
+        </p:nvSpPr>
+        <p:spPr>
+          <a:xfrm>
+            <a:off x="609600" y="838200"/>
+            <a:ext cx="10972800" cy="857250"/>
+          </a:xfrm>
+          <a:prstGeom prst="rect">
+            <a:avLst/>
+          </a:prstGeom>
+          <a:noFill/>
+          <a:ln w="0">
+            <a:noFill/>
+            <a:prstDash val="solid"/>
+          </a:ln>
+        </p:spPr>
+        <p:txBody>
+          <a:bodyPr/>
+          <a:lstStyle>
+            <a:defPPr>
+              <a:defRPr sz="3150" b="1">
+                <a:solidFill>
+                  <a:srgbClr val="142D4E"/>
+                </a:solidFill>
+                <a:latin typeface="Arial"/>
+                <a:ea typeface="Arial"/>
+                <a:cs typeface="Arial"/>
+              </a:defRPr>
+            </a:defPPr>
+          </a:lstStyle>
+          <a:p>
+            <a:pPr>
+              <a:defRPr sz="3150" b="1">
+                <a:solidFill>
+                  <a:srgbClr val="142D4E"/>
+                </a:solidFill>
+                <a:latin typeface="Arial"/>
+                <a:ea typeface="Arial"/>
+                <a:cs typeface="Arial"/>
+              </a:defRPr>
+            </a:pPr>
+            <a:r>
+              <a:rPr sz="3150" b="1">
+                <a:solidFill>
+                  <a:srgbClr val="142D4E"/>
+                </a:solidFill>
+                <a:latin typeface="Arial"/>
+                <a:ea typeface="Arial"/>
+                <a:cs typeface="Arial"/>
+              </a:rPr>
+              <a:t>Method 1 results at a glance</a:t>
+            </a:r>
+          </a:p>
+        </p:txBody>
+      </p:sp>
+      <p:sp>
+        <p:nvSpPr>
+          <p:cNvPr id="3" name="">
+            <a:extLst>
+              <a:ext uri="{FF2B5EF4-FFF2-40B4-BE49-F238E27FC236}">
+                <a16:creationId xmlns:a16="http://schemas.microsoft.com/office/drawing/2014/main" id="{8695F8C2-A08E-4AA5-A111-378AE00DBA0C}"/>
+              </a:ext>
+            </a:extLst>
+          </p:cNvPr>
+          <p:cNvSpPr>
+            <a:spLocks noGrp="1"/>
+          </p:cNvSpPr>
+          <p:nvPr/>
+        </p:nvSpPr>
+        <p:spPr>
+          <a:xfrm>
+            <a:off x="10953750" y="6343650"/>
+            <a:ext cx="619125" cy="238125"/>
+          </a:xfrm>
+          <a:prstGeom prst="rect">
+            <a:avLst/>
+          </a:prstGeom>
+          <a:noFill/>
+          <a:ln w="0">
+            <a:noFill/>
+            <a:prstDash val="solid"/>
+          </a:ln>
+        </p:spPr>
+        <p:txBody>
+          <a:bodyPr/>
+          <a:lstStyle>
+            <a:defPPr>
+              <a:defRPr sz="1200" b="0">
+                <a:solidFill>
+                  <a:srgbClr val="66758A"/>
+                </a:solidFill>
+                <a:latin typeface="Arial"/>
+                <a:ea typeface="Arial"/>
+                <a:cs typeface="Arial"/>
+              </a:defRPr>
+            </a:defPPr>
+          </a:lstStyle>
+          <a:p>
+            <a:pPr>
+              <a:defRPr sz="1200" b="0">
+                <a:solidFill>
+                  <a:srgbClr val="66758A"/>
+                </a:solidFill>
+                <a:latin typeface="Arial"/>
+                <a:ea typeface="Arial"/>
+                <a:cs typeface="Arial"/>
+              </a:defRPr>
+            </a:pPr>
+            <a:r>
+              <a:rPr sz="1200" b="0">
+                <a:solidFill>
+                  <a:srgbClr val="66758A"/>
+                </a:solidFill>
+                <a:latin typeface="Arial"/>
+                <a:ea typeface="Arial"/>
+                <a:cs typeface="Arial"/>
+              </a:rPr>
+              <a:t>12</a:t>
+            </a:r>
+          </a:p>
+        </p:txBody>
+      </p:sp>
+      <p:graphicFrame>
+        <p:nvGraphicFramePr>
+          <p:cNvPr id="8" name="Chart 7"/>
+          <p:cNvGraphicFramePr>
+            <a:graphicFrameLocks noGrp="1"/>
+          </p:cNvGraphicFramePr>
+          <p:nvPr/>
+        </p:nvGraphicFramePr>
+        <p:xfrm>
+          <a:off x="612648" y="1691640"/>
+          <a:ext cx="5852160" cy="3291840"/>
+        </p:xfrm>
+        <a:graphic>
+          <a:graphicData uri="http://schemas.openxmlformats.org/drawingml/2006/chart">
+            <c:chart xmlns:c="http://schemas.openxmlformats.org/drawingml/2006/chart" r:id="rId2"/>
+          </a:graphicData>
+        </a:graphic>
+      </p:graphicFrame>
+      <p:graphicFrame>
+        <p:nvGraphicFramePr>
+          <p:cNvPr id="9" name="Chart 8"/>
+          <p:cNvGraphicFramePr>
+            <a:graphicFrameLocks noGrp="1"/>
+          </p:cNvGraphicFramePr>
+          <p:nvPr/>
+        </p:nvGraphicFramePr>
+        <p:xfrm>
+          <a:off x="6583680" y="1691640"/>
+          <a:ext cx="5029200" cy="3291840"/>
+        </p:xfrm>
+        <a:graphic>
+          <a:graphicData uri="http://schemas.openxmlformats.org/drawingml/2006/chart">
+            <c:chart xmlns:c="http://schemas.openxmlformats.org/drawingml/2006/chart" r:id="rId3"/>
+          </a:graphicData>
+        </a:graphic>
+      </p:graphicFrame>
+      <p:sp>
+        <p:nvSpPr>
+          <p:cNvPr id="10" name="Rectangle 9"/>
+          <p:cNvSpPr/>
+          <p:nvPr/>
+        </p:nvSpPr>
+        <p:spPr>
+          <a:xfrm>
+            <a:off x="612648" y="5029200"/>
+            <a:ext cx="10972800" cy="777240"/>
+          </a:xfrm>
+          <a:prstGeom prst="rect">
+            <a:avLst/>
+          </a:prstGeom>
+          <a:solidFill>
+            <a:srgbClr val="FFFFFF"/>
+          </a:solidFill>
+          <a:ln>
+            <a:noFill/>
+          </a:ln>
+          <a:effectLst/>
+        </p:spPr>
+        <p:style>
+          <a:lnRef idx="1">
+            <a:schemeClr val="accent1"/>
+          </a:lnRef>
+          <a:fillRef idx="3">
+            <a:schemeClr val="accent1"/>
+          </a:fillRef>
+          <a:effectRef idx="2">
+            <a:schemeClr val="accent1"/>
+          </a:effectRef>
+          <a:fontRef idx="minor">
+            <a:schemeClr val="lt1"/>
+          </a:fontRef>
+        </p:style>
+        <p:txBody>
+          <a:bodyPr rtlCol="0" anchor="t" wrap="square" lIns="45720" rIns="45720" tIns="36576" bIns="36576"/>
+          <a:lstStyle/>
+          <a:p>
+            <a:pPr algn="l"/>
+            <a:r>
+              <a:rPr sz="1200" b="1">
+                <a:solidFill>
+                  <a:srgbClr val="142D4E"/>
+                </a:solidFill>
+                <a:latin typeface="Arial"/>
+              </a:rPr>
+              <a:t>How to read it: </a:t>
+            </a:r>
+            <a:r>
+              <a:rPr sz="1200" b="0">
+                <a:solidFill>
+                  <a:srgbClr val="233247"/>
+                </a:solidFill>
+                <a:latin typeface="Arial"/>
+              </a:rPr>
+              <a:t>left, adding the text lifts ROC-AUC from 0.76 to 0.97 on the same test reviews. Right, crashes and multiplayer bugs lead early negatives (29% against 24%), boss and balance later (34% against 25%); the themes are exploratory (blind check 35.5%).</a:t>
+            </a:r>
+          </a:p>
+        </p:txBody>
+      </p:sp>
+      <p:sp>
+        <p:nvSpPr>
+          <p:cNvPr id="11" name="Rectangle 10"/>
+          <p:cNvSpPr/>
+          <p:nvPr/>
+        </p:nvSpPr>
+        <p:spPr>
+          <a:xfrm>
+            <a:off x="612648" y="5916168"/>
+            <a:ext cx="10972800" cy="420624"/>
+          </a:xfrm>
+          <a:prstGeom prst="rect">
+            <a:avLst/>
+          </a:prstGeom>
+          <a:solidFill>
+            <a:srgbClr val="EEF2F7"/>
+          </a:solidFill>
+          <a:ln>
+            <a:noFill/>
+          </a:ln>
+          <a:effectLst/>
+        </p:spPr>
+        <p:style>
+          <a:lnRef idx="1">
+            <a:schemeClr val="accent1"/>
+          </a:lnRef>
+          <a:fillRef idx="3">
+            <a:schemeClr val="accent1"/>
+          </a:fillRef>
+          <a:effectRef idx="2">
+            <a:schemeClr val="accent1"/>
+          </a:effectRef>
+          <a:fontRef idx="minor">
+            <a:schemeClr val="lt1"/>
+          </a:fontRef>
+        </p:style>
+        <p:txBody>
+          <a:bodyPr rtlCol="0" anchor="ctr"/>
+          <a:lstStyle/>
+          <a:p>
+            <a:pPr algn="ctr"/>
+          </a:p>
+        </p:txBody>
+      </p:sp>
+      <p:sp>
+        <p:nvSpPr>
+          <p:cNvPr id="12" name="Rectangle 11"/>
+          <p:cNvSpPr/>
+          <p:nvPr/>
+        </p:nvSpPr>
+        <p:spPr>
+          <a:xfrm>
+            <a:off x="612648" y="5916168"/>
+            <a:ext cx="64008" cy="420624"/>
+          </a:xfrm>
+          <a:prstGeom prst="rect">
+            <a:avLst/>
+          </a:prstGeom>
+          <a:solidFill>
+            <a:srgbClr val="C44E52"/>
+          </a:solidFill>
+          <a:ln>
+            <a:noFill/>
+          </a:ln>
+          <a:effectLst/>
+        </p:spPr>
+        <p:style>
+          <a:lnRef idx="1">
+            <a:schemeClr val="accent1"/>
+          </a:lnRef>
+          <a:fillRef idx="3">
+            <a:schemeClr val="accent1"/>
+          </a:fillRef>
+          <a:effectRef idx="2">
+            <a:schemeClr val="accent1"/>
+          </a:effectRef>
+          <a:fontRef idx="minor">
+            <a:schemeClr val="lt1"/>
+          </a:fontRef>
+        </p:style>
+        <p:txBody>
+          <a:bodyPr rtlCol="0" anchor="ctr"/>
+          <a:lstStyle/>
+          <a:p>
+            <a:pPr algn="ctr"/>
+          </a:p>
+        </p:txBody>
+      </p:sp>
+      <p:sp>
+        <p:nvSpPr>
+          <p:cNvPr id="13" name="Rectangle 12"/>
+          <p:cNvSpPr/>
+          <p:nvPr/>
+        </p:nvSpPr>
+        <p:spPr>
+          <a:xfrm>
+            <a:off x="676656" y="5916168"/>
+            <a:ext cx="10908792" cy="420624"/>
+          </a:xfrm>
+          <a:prstGeom prst="rect">
+            <a:avLst/>
+          </a:prstGeom>
+          <a:solidFill>
+            <a:srgbClr val="EEF2F7"/>
+          </a:solidFill>
+          <a:ln>
+            <a:noFill/>
+          </a:ln>
+          <a:effectLst/>
+        </p:spPr>
+        <p:style>
+          <a:lnRef idx="1">
+            <a:schemeClr val="accent1"/>
+          </a:lnRef>
+          <a:fillRef idx="3">
+            <a:schemeClr val="accent1"/>
+          </a:fillRef>
+          <a:effectRef idx="2">
+            <a:schemeClr val="accent1"/>
+          </a:effectRef>
+          <a:fontRef idx="minor">
+            <a:schemeClr val="lt1"/>
+          </a:fontRef>
+        </p:style>
+        <p:txBody>
+          <a:bodyPr rtlCol="0" anchor="ctr" wrap="square" tIns="36576" bIns="36576"/>
+          <a:lstStyle/>
+          <a:p>
+            <a:pPr algn="l"/>
+            <a:r>
+              <a:rPr sz="1200" b="1">
+                <a:solidFill>
+                  <a:srgbClr val="C44E52"/>
+                </a:solidFill>
+                <a:latin typeface="Arial"/>
+              </a:rPr>
+              <a:t>Takeaway   </a:t>
+            </a:r>
+            <a:r>
+              <a:rPr sz="1200" b="0">
+                <a:solidFill>
+                  <a:srgbClr val="233247"/>
+                </a:solidFill>
+                <a:latin typeface="Arial"/>
+              </a:rPr>
+              <a:t>The words of a review carry the signal: a text model flags negative reviews far better than metadata, and the complaints change with playtime.</a:t>
+            </a:r>
+          </a:p>
+        </p:txBody>
+      </p:sp>
+    </p:spTree>
+  </p:cSld>
+  <p:clrMapOvr>
+    <a:masterClrMapping/>
+  </p:clrMapOvr>
 </p:sld>
 </file>
 
@@ -14387,6 +17007,473 @@
       </p:ext>
     </p:extLst>
   </p:cSld>
+</p:sld>
+</file>
+
+<file path=ppt/slides/slide20.xml><?xml version="1.0" encoding="utf-8"?>
+<p:sld xmlns:a="http://schemas.openxmlformats.org/drawingml/2006/main" xmlns:p="http://schemas.openxmlformats.org/presentationml/2006/main" xmlns:r="http://schemas.openxmlformats.org/officeDocument/2006/relationships">
+  <p:cSld>
+    <p:spTree>
+      <p:nvGrpSpPr>
+        <p:cNvPr id="1" name=""/>
+        <p:cNvGrpSpPr/>
+        <p:nvPr/>
+      </p:nvGrpSpPr>
+      <p:grpSpPr/>
+      <p:sp>
+        <p:nvSpPr>
+          <p:cNvPr id="7" name="">
+            <a:extLst>
+              <a:ext uri="{FF2B5EF4-FFF2-40B4-BE49-F238E27FC236}">
+                <a16:creationId xmlns:a16="http://schemas.microsoft.com/office/drawing/2014/main" id="{9F058891-18A5-414B-856B-FE11F25A696B}"/>
+              </a:ext>
+            </a:extLst>
+          </p:cNvPr>
+          <p:cNvSpPr>
+            <a:spLocks noGrp="1"/>
+          </p:cNvSpPr>
+          <p:nvPr/>
+        </p:nvSpPr>
+        <p:spPr>
+          <a:xfrm>
+            <a:off x="609600" y="342900"/>
+            <a:ext cx="10477500" cy="285750"/>
+          </a:xfrm>
+          <a:prstGeom prst="rect">
+            <a:avLst/>
+          </a:prstGeom>
+          <a:noFill/>
+          <a:ln w="0">
+            <a:noFill/>
+            <a:prstDash val="solid"/>
+          </a:ln>
+        </p:spPr>
+        <p:txBody>
+          <a:bodyPr/>
+          <a:lstStyle>
+            <a:defPPr>
+              <a:defRPr sz="1350" b="1">
+                <a:solidFill>
+                  <a:srgbClr val="157A80"/>
+                </a:solidFill>
+                <a:latin typeface="Arial"/>
+                <a:ea typeface="Arial"/>
+                <a:cs typeface="Arial"/>
+              </a:defRPr>
+            </a:defPPr>
+          </a:lstStyle>
+          <a:p>
+            <a:pPr>
+              <a:defRPr sz="1350" b="1">
+                <a:solidFill>
+                  <a:srgbClr val="157A80"/>
+                </a:solidFill>
+                <a:latin typeface="Arial"/>
+                <a:ea typeface="Arial"/>
+                <a:cs typeface="Arial"/>
+              </a:defRPr>
+            </a:pPr>
+            <a:r>
+              <a:rPr sz="1350" b="1">
+                <a:solidFill>
+                  <a:srgbClr val="157A80"/>
+                </a:solidFill>
+                <a:latin typeface="Arial"/>
+                <a:ea typeface="Arial"/>
+                <a:cs typeface="Arial"/>
+              </a:rPr>
+              <a:t>UNIT 3</a:t>
+            </a:r>
+          </a:p>
+        </p:txBody>
+      </p:sp>
+      <p:sp>
+        <p:nvSpPr>
+          <p:cNvPr id="2" name="">
+            <a:extLst>
+              <a:ext uri="{FF2B5EF4-FFF2-40B4-BE49-F238E27FC236}">
+                <a16:creationId xmlns:a16="http://schemas.microsoft.com/office/drawing/2014/main" id="{783AB2B7-C380-4333-8683-F6BBF01123FD}"/>
+              </a:ext>
+            </a:extLst>
+          </p:cNvPr>
+          <p:cNvSpPr>
+            <a:spLocks noGrp="1"/>
+          </p:cNvSpPr>
+          <p:nvPr/>
+        </p:nvSpPr>
+        <p:spPr>
+          <a:xfrm>
+            <a:off x="609600" y="838200"/>
+            <a:ext cx="10972800" cy="857250"/>
+          </a:xfrm>
+          <a:prstGeom prst="rect">
+            <a:avLst/>
+          </a:prstGeom>
+          <a:noFill/>
+          <a:ln w="0">
+            <a:noFill/>
+            <a:prstDash val="solid"/>
+          </a:ln>
+        </p:spPr>
+        <p:txBody>
+          <a:bodyPr/>
+          <a:lstStyle>
+            <a:defPPr>
+              <a:defRPr sz="3150" b="1">
+                <a:solidFill>
+                  <a:srgbClr val="142D4E"/>
+                </a:solidFill>
+                <a:latin typeface="Arial"/>
+                <a:ea typeface="Arial"/>
+                <a:cs typeface="Arial"/>
+              </a:defRPr>
+            </a:defPPr>
+          </a:lstStyle>
+          <a:p>
+            <a:pPr>
+              <a:defRPr sz="3150" b="1">
+                <a:solidFill>
+                  <a:srgbClr val="142D4E"/>
+                </a:solidFill>
+                <a:latin typeface="Arial"/>
+                <a:ea typeface="Arial"/>
+                <a:cs typeface="Arial"/>
+              </a:defRPr>
+            </a:pPr>
+            <a:r>
+              <a:rPr sz="3150" b="1">
+                <a:solidFill>
+                  <a:srgbClr val="142D4E"/>
+                </a:solidFill>
+                <a:latin typeface="Arial"/>
+                <a:ea typeface="Arial"/>
+                <a:cs typeface="Arial"/>
+              </a:rPr>
+              <a:t>Method 2 rules at a glance</a:t>
+            </a:r>
+          </a:p>
+        </p:txBody>
+      </p:sp>
+      <p:sp>
+        <p:nvSpPr>
+          <p:cNvPr id="3" name="">
+            <a:extLst>
+              <a:ext uri="{FF2B5EF4-FFF2-40B4-BE49-F238E27FC236}">
+                <a16:creationId xmlns:a16="http://schemas.microsoft.com/office/drawing/2014/main" id="{5260EA7B-3BBC-4C86-9EB4-FC754B5614C4}"/>
+              </a:ext>
+            </a:extLst>
+          </p:cNvPr>
+          <p:cNvSpPr>
+            <a:spLocks noGrp="1"/>
+          </p:cNvSpPr>
+          <p:nvPr/>
+        </p:nvSpPr>
+        <p:spPr>
+          <a:xfrm>
+            <a:off x="10953750" y="6343650"/>
+            <a:ext cx="619125" cy="238125"/>
+          </a:xfrm>
+          <a:prstGeom prst="rect">
+            <a:avLst/>
+          </a:prstGeom>
+          <a:noFill/>
+          <a:ln w="0">
+            <a:noFill/>
+            <a:prstDash val="solid"/>
+          </a:ln>
+        </p:spPr>
+        <p:txBody>
+          <a:bodyPr/>
+          <a:lstStyle>
+            <a:defPPr>
+              <a:defRPr sz="1200" b="0">
+                <a:solidFill>
+                  <a:srgbClr val="66758A"/>
+                </a:solidFill>
+                <a:latin typeface="Arial"/>
+                <a:ea typeface="Arial"/>
+                <a:cs typeface="Arial"/>
+              </a:defRPr>
+            </a:defPPr>
+          </a:lstStyle>
+          <a:p>
+            <a:pPr>
+              <a:defRPr sz="1200" b="0">
+                <a:solidFill>
+                  <a:srgbClr val="66758A"/>
+                </a:solidFill>
+                <a:latin typeface="Arial"/>
+                <a:ea typeface="Arial"/>
+                <a:cs typeface="Arial"/>
+              </a:defRPr>
+            </a:pPr>
+            <a:r>
+              <a:rPr sz="1200" b="0">
+                <a:solidFill>
+                  <a:srgbClr val="66758A"/>
+                </a:solidFill>
+                <a:latin typeface="Arial"/>
+                <a:ea typeface="Arial"/>
+                <a:cs typeface="Arial"/>
+              </a:rPr>
+              <a:t>15</a:t>
+            </a:r>
+          </a:p>
+        </p:txBody>
+      </p:sp>
+      <p:graphicFrame>
+        <p:nvGraphicFramePr>
+          <p:cNvPr id="8" name="Chart 7"/>
+          <p:cNvGraphicFramePr>
+            <a:graphicFrameLocks noGrp="1"/>
+          </p:cNvGraphicFramePr>
+          <p:nvPr/>
+        </p:nvGraphicFramePr>
+        <p:xfrm>
+          <a:off x="612648" y="1691640"/>
+          <a:ext cx="6949440" cy="3291840"/>
+        </p:xfrm>
+        <a:graphic>
+          <a:graphicData uri="http://schemas.openxmlformats.org/drawingml/2006/chart">
+            <c:chart xmlns:c="http://schemas.openxmlformats.org/drawingml/2006/chart" r:id="rId2"/>
+          </a:graphicData>
+        </a:graphic>
+      </p:graphicFrame>
+      <p:graphicFrame>
+        <p:nvGraphicFramePr>
+          <p:cNvPr id="9" name="Chart 8"/>
+          <p:cNvGraphicFramePr>
+            <a:graphicFrameLocks noGrp="1"/>
+          </p:cNvGraphicFramePr>
+          <p:nvPr/>
+        </p:nvGraphicFramePr>
+        <p:xfrm>
+          <a:off x="7680960" y="1691640"/>
+          <a:ext cx="3931920" cy="3291840"/>
+        </p:xfrm>
+        <a:graphic>
+          <a:graphicData uri="http://schemas.openxmlformats.org/drawingml/2006/chart">
+            <c:chart xmlns:c="http://schemas.openxmlformats.org/drawingml/2006/chart" r:id="rId3"/>
+          </a:graphicData>
+        </a:graphic>
+      </p:graphicFrame>
+      <p:sp>
+        <p:nvSpPr>
+          <p:cNvPr id="10" name="Rectangle 9"/>
+          <p:cNvSpPr/>
+          <p:nvPr/>
+        </p:nvSpPr>
+        <p:spPr>
+          <a:xfrm>
+            <a:off x="612648" y="5029200"/>
+            <a:ext cx="10972800" cy="777240"/>
+          </a:xfrm>
+          <a:prstGeom prst="rect">
+            <a:avLst/>
+          </a:prstGeom>
+          <a:solidFill>
+            <a:srgbClr val="FFFFFF"/>
+          </a:solidFill>
+          <a:ln>
+            <a:noFill/>
+          </a:ln>
+          <a:effectLst/>
+        </p:spPr>
+        <p:style>
+          <a:lnRef idx="1">
+            <a:schemeClr val="accent1"/>
+          </a:lnRef>
+          <a:fillRef idx="3">
+            <a:schemeClr val="accent1"/>
+          </a:fillRef>
+          <a:effectRef idx="2">
+            <a:schemeClr val="accent1"/>
+          </a:effectRef>
+          <a:fontRef idx="minor">
+            <a:schemeClr val="lt1"/>
+          </a:fontRef>
+        </p:style>
+        <p:txBody>
+          <a:bodyPr rtlCol="0" anchor="t" wrap="square" lIns="45720" rIns="45720" tIns="36576" bIns="36576"/>
+          <a:lstStyle/>
+          <a:p>
+            <a:pPr algn="l"/>
+            <a:r>
+              <a:rPr sz="1200" b="1">
+                <a:solidFill>
+                  <a:srgbClr val="142D4E"/>
+                </a:solidFill>
+                <a:latin typeface="Arial"/>
+              </a:rPr>
+              <a:t>How to read it: </a:t>
+            </a:r>
+            <a:r>
+              <a:rPr sz="1200" b="0">
+                <a:solidFill>
+                  <a:srgbClr val="233247"/>
+                </a:solidFill>
+                <a:latin typeface="Arial"/>
+              </a:rPr>
+              <a:t>each pair of bars is one rule: the share of training games with that tag combination that reached the Strong tier, then the same share on unseen test games (4 to 14 games per rule, so noisy). About two-thirds of rules hold in every configuration.</a:t>
+            </a:r>
+          </a:p>
+        </p:txBody>
+      </p:sp>
+      <p:sp>
+        <p:nvSpPr>
+          <p:cNvPr id="11" name="Rectangle 10"/>
+          <p:cNvSpPr/>
+          <p:nvPr/>
+        </p:nvSpPr>
+        <p:spPr>
+          <a:xfrm>
+            <a:off x="612648" y="5916168"/>
+            <a:ext cx="10972800" cy="420624"/>
+          </a:xfrm>
+          <a:prstGeom prst="rect">
+            <a:avLst/>
+          </a:prstGeom>
+          <a:solidFill>
+            <a:srgbClr val="EEF2F7"/>
+          </a:solidFill>
+          <a:ln>
+            <a:noFill/>
+          </a:ln>
+          <a:effectLst/>
+        </p:spPr>
+        <p:style>
+          <a:lnRef idx="1">
+            <a:schemeClr val="accent1"/>
+          </a:lnRef>
+          <a:fillRef idx="3">
+            <a:schemeClr val="accent1"/>
+          </a:fillRef>
+          <a:effectRef idx="2">
+            <a:schemeClr val="accent1"/>
+          </a:effectRef>
+          <a:fontRef idx="minor">
+            <a:schemeClr val="lt1"/>
+          </a:fontRef>
+        </p:style>
+        <p:txBody>
+          <a:bodyPr rtlCol="0" anchor="ctr"/>
+          <a:lstStyle/>
+          <a:p>
+            <a:pPr algn="ctr"/>
+          </a:p>
+        </p:txBody>
+      </p:sp>
+      <p:sp>
+        <p:nvSpPr>
+          <p:cNvPr id="12" name="Rectangle 11"/>
+          <p:cNvSpPr/>
+          <p:nvPr/>
+        </p:nvSpPr>
+        <p:spPr>
+          <a:xfrm>
+            <a:off x="612648" y="5916168"/>
+            <a:ext cx="64008" cy="420624"/>
+          </a:xfrm>
+          <a:prstGeom prst="rect">
+            <a:avLst/>
+          </a:prstGeom>
+          <a:solidFill>
+            <a:srgbClr val="C44E52"/>
+          </a:solidFill>
+          <a:ln>
+            <a:noFill/>
+          </a:ln>
+          <a:effectLst/>
+        </p:spPr>
+        <p:style>
+          <a:lnRef idx="1">
+            <a:schemeClr val="accent1"/>
+          </a:lnRef>
+          <a:fillRef idx="3">
+            <a:schemeClr val="accent1"/>
+          </a:fillRef>
+          <a:effectRef idx="2">
+            <a:schemeClr val="accent1"/>
+          </a:effectRef>
+          <a:fontRef idx="minor">
+            <a:schemeClr val="lt1"/>
+          </a:fontRef>
+        </p:style>
+        <p:txBody>
+          <a:bodyPr rtlCol="0" anchor="ctr"/>
+          <a:lstStyle/>
+          <a:p>
+            <a:pPr algn="ctr"/>
+          </a:p>
+        </p:txBody>
+      </p:sp>
+      <p:sp>
+        <p:nvSpPr>
+          <p:cNvPr id="13" name="Rectangle 12"/>
+          <p:cNvSpPr/>
+          <p:nvPr/>
+        </p:nvSpPr>
+        <p:spPr>
+          <a:xfrm>
+            <a:off x="676656" y="5916168"/>
+            <a:ext cx="10908792" cy="420624"/>
+          </a:xfrm>
+          <a:prstGeom prst="rect">
+            <a:avLst/>
+          </a:prstGeom>
+          <a:solidFill>
+            <a:srgbClr val="EEF2F7"/>
+          </a:solidFill>
+          <a:ln>
+            <a:noFill/>
+          </a:ln>
+          <a:effectLst/>
+        </p:spPr>
+        <p:style>
+          <a:lnRef idx="1">
+            <a:schemeClr val="accent1"/>
+          </a:lnRef>
+          <a:fillRef idx="3">
+            <a:schemeClr val="accent1"/>
+          </a:fillRef>
+          <a:effectRef idx="2">
+            <a:schemeClr val="accent1"/>
+          </a:effectRef>
+          <a:fontRef idx="minor">
+            <a:schemeClr val="lt1"/>
+          </a:fontRef>
+        </p:style>
+        <p:txBody>
+          <a:bodyPr rtlCol="0" anchor="ctr" wrap="square" tIns="36576" bIns="36576"/>
+          <a:lstStyle/>
+          <a:p>
+            <a:pPr algn="l"/>
+            <a:r>
+              <a:rPr sz="1200" b="1">
+                <a:solidFill>
+                  <a:srgbClr val="C44E52"/>
+                </a:solidFill>
+                <a:latin typeface="Arial"/>
+              </a:rPr>
+              <a:t>Takeaway   </a:t>
+            </a:r>
+            <a:r>
+              <a:rPr sz="1200" b="0">
+                <a:solidFill>
+                  <a:srgbClr val="233247"/>
+                </a:solidFill>
+                <a:latin typeface="Arial"/>
+              </a:rPr>
+              <a:t>Strong combinations mostly hold up on unseen games, but test shares are lower than training shares and the groups are small: treat each rule as a hypothesis.</a:t>
+            </a:r>
+          </a:p>
+        </p:txBody>
+      </p:sp>
+    </p:spTree>
+  </p:cSld>
+  <p:clrMapOvr>
+    <a:masterClrMapping/>
+  </p:clrMapOvr>
 </p:sld>
 </file>
 
@@ -21058,7 +24145,7 @@
                 <a:ea typeface="Arial"/>
                 <a:cs typeface="Arial"/>
               </a:rPr>
-              <a:t>09</a:t>
+              <a:t>10</a:t>
             </a:r>
           </a:p>
         </p:txBody>

</xml_diff>